<commit_message>
docs: simplify GOAI submission language
</commit_message>
<xml_diff>
--- a/competition/deepseek-harness-goutoujunshi/submission/狗头军师_GOAI2026_无界应用_初赛方案.pptx
+++ b/competition/deepseek-harness-goutoujunshi/submission/狗头军师_GOAI2026_无界应用_初赛方案.pptx
@@ -2,22 +2,22 @@
 <file path=ppt/presentation.xml><?xml version="1.0" encoding="utf-8"?>
 <p:presentation xmlns:p="http://schemas.openxmlformats.org/presentationml/2006/main">
   <p:sldMasterIdLst>
-    <p:sldMasterId xmlns:r="http://schemas.openxmlformats.org/officeDocument/2006/relationships" id="2147483648" r:id="R6bd87820b15a4e34"/>
+    <p:sldMasterId xmlns:r="http://schemas.openxmlformats.org/officeDocument/2006/relationships" id="2147483648" r:id="Re3b0fece2a4d459d"/>
   </p:sldMasterIdLst>
   <p:notesMasterIdLst>
-    <p:notesMasterId xmlns:r="http://schemas.openxmlformats.org/officeDocument/2006/relationships" r:id="Rbd7235c44800455e"/>
+    <p:notesMasterId xmlns:r="http://schemas.openxmlformats.org/officeDocument/2006/relationships" r:id="R946687d558bc488b"/>
   </p:notesMasterIdLst>
   <p:sldIdLst>
-    <p:sldId xmlns:r="http://schemas.openxmlformats.org/officeDocument/2006/relationships" id="256" r:id="Rbb45c45124eb497a"/>
-    <p:sldId xmlns:r="http://schemas.openxmlformats.org/officeDocument/2006/relationships" id="257" r:id="R3e6c212cd1c3415c"/>
-    <p:sldId xmlns:r="http://schemas.openxmlformats.org/officeDocument/2006/relationships" id="258" r:id="R122c0614a0bb413f"/>
-    <p:sldId xmlns:r="http://schemas.openxmlformats.org/officeDocument/2006/relationships" id="259" r:id="R5d68ca2db3154d55"/>
-    <p:sldId xmlns:r="http://schemas.openxmlformats.org/officeDocument/2006/relationships" id="260" r:id="Rccd266ab41ac44e9"/>
-    <p:sldId xmlns:r="http://schemas.openxmlformats.org/officeDocument/2006/relationships" id="261" r:id="R8adb0543697b4981"/>
-    <p:sldId xmlns:r="http://schemas.openxmlformats.org/officeDocument/2006/relationships" id="262" r:id="R64c6b37fdcd445fc"/>
-    <p:sldId xmlns:r="http://schemas.openxmlformats.org/officeDocument/2006/relationships" id="263" r:id="R4eb122e254c74876"/>
-    <p:sldId xmlns:r="http://schemas.openxmlformats.org/officeDocument/2006/relationships" id="264" r:id="Ra9bdc62344a34530"/>
-    <p:sldId xmlns:r="http://schemas.openxmlformats.org/officeDocument/2006/relationships" id="265" r:id="Rc18cca130e8e48b3"/>
+    <p:sldId xmlns:r="http://schemas.openxmlformats.org/officeDocument/2006/relationships" id="256" r:id="Re511ab490f5c49de"/>
+    <p:sldId xmlns:r="http://schemas.openxmlformats.org/officeDocument/2006/relationships" id="257" r:id="R2b905188f6134692"/>
+    <p:sldId xmlns:r="http://schemas.openxmlformats.org/officeDocument/2006/relationships" id="258" r:id="R3eddbb4006fb42dd"/>
+    <p:sldId xmlns:r="http://schemas.openxmlformats.org/officeDocument/2006/relationships" id="259" r:id="Ra59813aebdee419f"/>
+    <p:sldId xmlns:r="http://schemas.openxmlformats.org/officeDocument/2006/relationships" id="260" r:id="R7c9e59518b224498"/>
+    <p:sldId xmlns:r="http://schemas.openxmlformats.org/officeDocument/2006/relationships" id="261" r:id="Rb86f7459fa8044a7"/>
+    <p:sldId xmlns:r="http://schemas.openxmlformats.org/officeDocument/2006/relationships" id="262" r:id="Rc7c40f06d46d489a"/>
+    <p:sldId xmlns:r="http://schemas.openxmlformats.org/officeDocument/2006/relationships" id="263" r:id="R473487fb79154584"/>
+    <p:sldId xmlns:r="http://schemas.openxmlformats.org/officeDocument/2006/relationships" id="264" r:id="R5fd3eb4dde694929"/>
+    <p:sldId xmlns:r="http://schemas.openxmlformats.org/officeDocument/2006/relationships" id="265" r:id="R5c0322be6b6d4101"/>
   </p:sldIdLst>
   <p:sldSz cx="12192000" cy="6858000"/>
   <p:notesSz cx="6858000" cy="9144000"/>
@@ -1249,7 +1249,7 @@
   </p:cSld>
   <p:clrMap bg1="lt1" tx1="dk1" bg2="lt2" tx2="dk2" accent1="accent1" accent2="accent2" accent3="accent3" accent4="accent4" accent5="accent5" accent6="accent6" hlink="hlink" folHlink="folHlink"/>
   <p:sldLayoutIdLst>
-    <p:sldLayoutId xmlns:r="http://schemas.openxmlformats.org/officeDocument/2006/relationships" id="2147483649" r:id="R6f27845ca3d84c4b"/>
+    <p:sldLayoutId xmlns:r="http://schemas.openxmlformats.org/officeDocument/2006/relationships" id="2147483649" r:id="R87c89404335844d9"/>
   </p:sldLayoutIdLst>
   <p:txStyles>
     <p:titleStyle>
@@ -1800,7 +1800,7 @@
           <p:cNvPr id="12" name="">
             <a:extLst xmlns:a="http://schemas.openxmlformats.org/drawingml/2006/main">
               <a:ext uri="{FF2B5EF4-FFF2-40B4-BE49-F238E27FC236}">
-                <a16:creationId xmlns:a16="http://schemas.microsoft.com/office/drawing/2014/main" id="{7D154F42-3304-4242-BDA0-7480EBB76F83}"/>
+                <a16:creationId xmlns:a16="http://schemas.microsoft.com/office/drawing/2014/main" id="{8FA01186-BA60-4782-9E62-F6B0C6861D37}"/>
               </a:ext>
             </a:extLst>
           </p:cNvPr>
@@ -1833,7 +1833,7 @@
           <p:cNvPr id="2" name="">
             <a:extLst xmlns:a="http://schemas.openxmlformats.org/drawingml/2006/main">
               <a:ext uri="{FF2B5EF4-FFF2-40B4-BE49-F238E27FC236}">
-                <a16:creationId xmlns:a16="http://schemas.microsoft.com/office/drawing/2014/main" id="{194E4A39-21CF-42E7-B860-9411AC01AF6C}"/>
+                <a16:creationId xmlns:a16="http://schemas.microsoft.com/office/drawing/2014/main" id="{1F12C56C-ED5C-4C1E-B1E9-EF3512B69D47}"/>
               </a:ext>
             </a:extLst>
           </p:cNvPr>
@@ -1883,7 +1883,7 @@
           <p:cNvPr id="3" name="">
             <a:extLst xmlns:a="http://schemas.openxmlformats.org/drawingml/2006/main">
               <a:ext uri="{FF2B5EF4-FFF2-40B4-BE49-F238E27FC236}">
-                <a16:creationId xmlns:a16="http://schemas.microsoft.com/office/drawing/2014/main" id="{F6E560C4-048A-471F-9EE0-EB2C35CD4212}"/>
+                <a16:creationId xmlns:a16="http://schemas.microsoft.com/office/drawing/2014/main" id="{BCB2F691-AD47-4F72-8B11-C2BBD41B3D6B}"/>
               </a:ext>
             </a:extLst>
           </p:cNvPr>
@@ -1933,7 +1933,7 @@
           <p:cNvPr id="4" name="">
             <a:extLst xmlns:a="http://schemas.openxmlformats.org/drawingml/2006/main">
               <a:ext uri="{FF2B5EF4-FFF2-40B4-BE49-F238E27FC236}">
-                <a16:creationId xmlns:a16="http://schemas.microsoft.com/office/drawing/2014/main" id="{6D9A6EA4-F739-4D0A-8AC4-4EAA8A354DBC}"/>
+                <a16:creationId xmlns:a16="http://schemas.microsoft.com/office/drawing/2014/main" id="{CF737E77-8A0A-4F75-B49F-7D772B7ACBB2}"/>
               </a:ext>
             </a:extLst>
           </p:cNvPr>
@@ -1945,7 +1945,7 @@
         <p:spPr>
           <a:xfrm xmlns:a="http://schemas.openxmlformats.org/drawingml/2006/main">
             <a:off x="685800" y="2247900"/>
-            <a:ext cx="5905500" cy="590550"/>
+            <a:ext cx="6477000" cy="590550"/>
           </a:xfrm>
           <a:prstGeom xmlns:a="http://schemas.openxmlformats.org/drawingml/2006/main" prst="rect">
             <a:avLst/>
@@ -1973,7 +1973,7 @@
                   <a:srgbClr val="FFE2F1"/>
                 </a:solidFill>
               </a:rPr>
-              <a:t>关系决策 Agent</a:t>
+              <a:t>手机和电脑里的感情军师</a:t>
             </a:r>
           </a:p>
         </p:txBody>
@@ -1983,7 +1983,7 @@
           <p:cNvPr id="5" name="">
             <a:extLst xmlns:a="http://schemas.openxmlformats.org/drawingml/2006/main">
               <a:ext uri="{FF2B5EF4-FFF2-40B4-BE49-F238E27FC236}">
-                <a16:creationId xmlns:a16="http://schemas.microsoft.com/office/drawing/2014/main" id="{7A0716A7-42A0-498F-BAA4-D35EF044BDAB}"/>
+                <a16:creationId xmlns:a16="http://schemas.microsoft.com/office/drawing/2014/main" id="{D641AFE0-AF44-4AAF-B538-E549BADAB50F}"/>
               </a:ext>
             </a:extLst>
           </p:cNvPr>
@@ -2011,36 +2011,36 @@
           <a:lstStyle xmlns:a="http://schemas.openxmlformats.org/drawingml/2006/main"/>
           <a:p xmlns:a="http://schemas.openxmlformats.org/drawingml/2006/main">
             <a:pPr algn="l">
-              <a:defRPr sz="1800" b="0">
+              <a:defRPr sz="2100" b="0">
                 <a:solidFill>
                   <a:srgbClr val="F3D5E4"/>
                 </a:solidFill>
               </a:defRPr>
             </a:pPr>
             <a:r>
-              <a:rPr sz="1800" b="0">
+              <a:rPr sz="2100" b="0">
                 <a:solidFill>
                   <a:srgbClr val="F3D5E4"/>
                 </a:solidFill>
               </a:rPr>
-              <a:t>把高情绪、低确定性的关系困惑，</a:t>
-            </a:r>
-          </a:p>
-          <a:p xmlns:a="http://schemas.openxmlformats.org/drawingml/2006/main">
-            <a:pPr algn="l">
-              <a:defRPr sz="1800" b="0">
+              <a:t>帮用户理清关系，</a:t>
+            </a:r>
+          </a:p>
+          <a:p xmlns:a="http://schemas.openxmlformats.org/drawingml/2006/main">
+            <a:pPr algn="l">
+              <a:defRPr sz="2100" b="0">
                 <a:solidFill>
                   <a:srgbClr val="F3D5E4"/>
                 </a:solidFill>
               </a:defRPr>
             </a:pPr>
             <a:r>
-              <a:rPr sz="1800" b="0">
+              <a:rPr sz="2100" b="0">
                 <a:solidFill>
                   <a:srgbClr val="F3D5E4"/>
                 </a:solidFill>
               </a:rPr>
-              <a:t>变成可观察、可停止、由用户确认的行动闭环。</a:t>
+              <a:t>想好下一步。</a:t>
             </a:r>
           </a:p>
         </p:txBody>
@@ -2050,7 +2050,7 @@
           <p:cNvPr id="6" name="">
             <a:extLst xmlns:a="http://schemas.openxmlformats.org/drawingml/2006/main">
               <a:ext uri="{FF2B5EF4-FFF2-40B4-BE49-F238E27FC236}">
-                <a16:creationId xmlns:a16="http://schemas.microsoft.com/office/drawing/2014/main" id="{68D1F52A-73E7-4B8A-A7D6-480DFF231E27}"/>
+                <a16:creationId xmlns:a16="http://schemas.microsoft.com/office/drawing/2014/main" id="{F502A424-9692-4D22-B203-22E3AD2A5969}"/>
               </a:ext>
             </a:extLst>
           </p:cNvPr>
@@ -2087,7 +2087,7 @@
           <p:nvPr/>
         </p:nvPicPr>
         <p:blipFill>
-          <a:blip xmlns:r="http://schemas.openxmlformats.org/officeDocument/2006/relationships" xmlns:a="http://schemas.openxmlformats.org/drawingml/2006/main" r:embed="R1684d499fc944016"/>
+          <a:blip xmlns:r="http://schemas.openxmlformats.org/officeDocument/2006/relationships" xmlns:a="http://schemas.openxmlformats.org/drawingml/2006/main" r:embed="R2a187a3fc5b342a4"/>
           <a:stretch xmlns:a="http://schemas.openxmlformats.org/drawingml/2006/main"/>
         </p:blipFill>
         <p:spPr>
@@ -2105,7 +2105,7 @@
           <p:cNvPr id="8" name="">
             <a:extLst xmlns:a="http://schemas.openxmlformats.org/drawingml/2006/main">
               <a:ext uri="{FF2B5EF4-FFF2-40B4-BE49-F238E27FC236}">
-                <a16:creationId xmlns:a16="http://schemas.microsoft.com/office/drawing/2014/main" id="{2EF6B4B1-4ACA-413F-8A5E-E03B448F5C17}"/>
+                <a16:creationId xmlns:a16="http://schemas.microsoft.com/office/drawing/2014/main" id="{EB8FFCAE-9184-4CB5-B9B2-E0506CA16E35}"/>
               </a:ext>
             </a:extLst>
           </p:cNvPr>
@@ -2155,19 +2155,19 @@
           <p:cNvPr id="9" name="">
             <a:extLst xmlns:a="http://schemas.openxmlformats.org/drawingml/2006/main">
               <a:ext uri="{FF2B5EF4-FFF2-40B4-BE49-F238E27FC236}">
-                <a16:creationId xmlns:a16="http://schemas.microsoft.com/office/drawing/2014/main" id="{44BEF963-72B9-4C3D-90EE-08F682F4B1A0}"/>
-              </a:ext>
-            </a:extLst>
-          </p:cNvPr>
-          <p:cNvSpPr>
-            <a:spLocks xmlns:a="http://schemas.openxmlformats.org/drawingml/2006/main" noGrp="1"/>
-          </p:cNvSpPr>
-          <p:nvPr/>
-        </p:nvSpPr>
-        <p:spPr>
-          <a:xfrm xmlns:a="http://schemas.openxmlformats.org/drawingml/2006/main">
-            <a:off x="8239125" y="4410075"/>
-            <a:ext cx="2381250" cy="266700"/>
+                <a16:creationId xmlns:a16="http://schemas.microsoft.com/office/drawing/2014/main" id="{46EBE6A0-A414-4DED-A38C-3FCFE85D599F}"/>
+              </a:ext>
+            </a:extLst>
+          </p:cNvPr>
+          <p:cNvSpPr>
+            <a:spLocks xmlns:a="http://schemas.openxmlformats.org/drawingml/2006/main" noGrp="1"/>
+          </p:cNvSpPr>
+          <p:nvPr/>
+        </p:nvSpPr>
+        <p:spPr>
+          <a:xfrm xmlns:a="http://schemas.openxmlformats.org/drawingml/2006/main">
+            <a:off x="8096250" y="4410075"/>
+            <a:ext cx="2667000" cy="266700"/>
           </a:xfrm>
           <a:prstGeom xmlns:a="http://schemas.openxmlformats.org/drawingml/2006/main" prst="rect">
             <a:avLst/>
@@ -2195,7 +2195,7 @@
                   <a:srgbClr val="765C6A"/>
                 </a:solidFill>
               </a:rPr>
-              <a:t>真实插件集成 · 开源可复现</a:t>
+              <a:t>真的接入 DeepSeek · 代码公开</a:t>
             </a:r>
           </a:p>
         </p:txBody>
@@ -2205,7 +2205,7 @@
           <p:cNvPr id="10" name="">
             <a:extLst xmlns:a="http://schemas.openxmlformats.org/drawingml/2006/main">
               <a:ext uri="{FF2B5EF4-FFF2-40B4-BE49-F238E27FC236}">
-                <a16:creationId xmlns:a16="http://schemas.microsoft.com/office/drawing/2014/main" id="{87AAAF34-98FE-4F27-B255-86E4C93001D3}"/>
+                <a16:creationId xmlns:a16="http://schemas.microsoft.com/office/drawing/2014/main" id="{61DFC756-A772-44FE-9FB0-0E31A34F8A48}"/>
               </a:ext>
             </a:extLst>
           </p:cNvPr>
@@ -2255,7 +2255,7 @@
           <p:cNvPr id="11" name="">
             <a:extLst xmlns:a="http://schemas.openxmlformats.org/drawingml/2006/main">
               <a:ext uri="{FF2B5EF4-FFF2-40B4-BE49-F238E27FC236}">
-                <a16:creationId xmlns:a16="http://schemas.microsoft.com/office/drawing/2014/main" id="{347EE6CD-BA93-42B2-8FA1-3B2BE885B8A1}"/>
+                <a16:creationId xmlns:a16="http://schemas.microsoft.com/office/drawing/2014/main" id="{E76951C6-7C88-4EF3-9C1F-2BD1AF8DFA1F}"/>
               </a:ext>
             </a:extLst>
           </p:cNvPr>
@@ -2303,7 +2303,7 @@
     </p:spTree>
     <p:extLst>
       <p:ext uri="{BB962C8B-B14F-4D97-AF65-F5344CB8AC3E}">
-        <p14:creationId xmlns:p14="http://schemas.microsoft.com/office/powerpoint/2010/main" val="177938529"/>
+        <p14:creationId xmlns:p14="http://schemas.microsoft.com/office/powerpoint/2010/main" val="742015826"/>
       </p:ext>
     </p:extLst>
   </p:cSld>
@@ -2334,7 +2334,7 @@
           <p:cNvPr id="10" name="">
             <a:extLst xmlns:a="http://schemas.openxmlformats.org/drawingml/2006/main">
               <a:ext uri="{FF2B5EF4-FFF2-40B4-BE49-F238E27FC236}">
-                <a16:creationId xmlns:a16="http://schemas.microsoft.com/office/drawing/2014/main" id="{D468A40B-6E80-47CE-811A-DE608F83E07C}"/>
+                <a16:creationId xmlns:a16="http://schemas.microsoft.com/office/drawing/2014/main" id="{885EF384-2CA5-495B-AD1E-F0DA2F5BF3FD}"/>
               </a:ext>
             </a:extLst>
           </p:cNvPr>
@@ -2374,7 +2374,7 @@
                   <a:srgbClr val="FF168F"/>
                 </a:solidFill>
               </a:rPr>
-              <a:t>狗头军师 · 关系决策 Agent</a:t>
+              <a:t>狗头军师 · 感情军师</a:t>
             </a:r>
           </a:p>
         </p:txBody>
@@ -2384,7 +2384,7 @@
           <p:cNvPr id="2" name="">
             <a:extLst xmlns:a="http://schemas.openxmlformats.org/drawingml/2006/main">
               <a:ext uri="{FF2B5EF4-FFF2-40B4-BE49-F238E27FC236}">
-                <a16:creationId xmlns:a16="http://schemas.microsoft.com/office/drawing/2014/main" id="{2CF28CED-94AA-4CE6-B4C3-C978ED511665}"/>
+                <a16:creationId xmlns:a16="http://schemas.microsoft.com/office/drawing/2014/main" id="{456B24FC-249F-4C32-B998-FB2736929345}"/>
               </a:ext>
             </a:extLst>
           </p:cNvPr>
@@ -2434,7 +2434,7 @@
           <p:cNvPr id="3" name="">
             <a:extLst xmlns:a="http://schemas.openxmlformats.org/drawingml/2006/main">
               <a:ext uri="{FF2B5EF4-FFF2-40B4-BE49-F238E27FC236}">
-                <a16:creationId xmlns:a16="http://schemas.microsoft.com/office/drawing/2014/main" id="{C1B69C20-8739-4319-A345-82B501235450}"/>
+                <a16:creationId xmlns:a16="http://schemas.microsoft.com/office/drawing/2014/main" id="{7A31886C-182A-4A63-A8C4-C61A590EB933}"/>
               </a:ext>
             </a:extLst>
           </p:cNvPr>
@@ -2474,7 +2474,7 @@
                   <a:srgbClr val="FFE2F1"/>
                 </a:solidFill>
               </a:rPr>
-              <a:t>而是帮用户做出下一步</a:t>
+              <a:t>而是帮用户看清事实，</a:t>
             </a:r>
           </a:p>
           <a:p xmlns:a="http://schemas.openxmlformats.org/drawingml/2006/main">
@@ -2491,7 +2491,7 @@
                   <a:srgbClr val="FFE2F1"/>
                 </a:solidFill>
               </a:rPr>
-              <a:t>可验证的选择。</a:t>
+              <a:t>想好下一步。</a:t>
             </a:r>
           </a:p>
         </p:txBody>
@@ -2501,7 +2501,7 @@
           <p:cNvPr id="4" name="">
             <a:extLst xmlns:a="http://schemas.openxmlformats.org/drawingml/2006/main">
               <a:ext uri="{FF2B5EF4-FFF2-40B4-BE49-F238E27FC236}">
-                <a16:creationId xmlns:a16="http://schemas.microsoft.com/office/drawing/2014/main" id="{00774258-26A4-43D9-92ED-D5F8465C5721}"/>
+                <a16:creationId xmlns:a16="http://schemas.microsoft.com/office/drawing/2014/main" id="{B7E0C164-674E-4EAC-A20E-EB1F845E0B2E}"/>
               </a:ext>
             </a:extLst>
           </p:cNvPr>
@@ -2534,7 +2534,7 @@
           <p:cNvPr id="5" name="">
             <a:extLst xmlns:a="http://schemas.openxmlformats.org/drawingml/2006/main">
               <a:ext uri="{FF2B5EF4-FFF2-40B4-BE49-F238E27FC236}">
-                <a16:creationId xmlns:a16="http://schemas.microsoft.com/office/drawing/2014/main" id="{E4471DFD-9E1F-4A12-B1B8-2BF306D1AD3C}"/>
+                <a16:creationId xmlns:a16="http://schemas.microsoft.com/office/drawing/2014/main" id="{0C311AFA-6453-4BDA-8DCB-F91DB5480445}"/>
               </a:ext>
             </a:extLst>
           </p:cNvPr>
@@ -2574,7 +2574,7 @@
                   <a:srgbClr val="EBCADA"/>
                 </a:solidFill>
               </a:rPr>
-              <a:t>已完成：真实 Harness 集成 · 公开 Demo · 证据 K 线 · 安全边界 · 10/10 测试</a:t>
+              <a:t>现在已有：真实 DeepSeek 接入 · 公开案例 · 关系 K 线 · 隐私保护 · 10/10 测试</a:t>
             </a:r>
           </a:p>
         </p:txBody>
@@ -2584,7 +2584,7 @@
           <p:cNvPr id="6" name="">
             <a:extLst xmlns:a="http://schemas.openxmlformats.org/drawingml/2006/main">
               <a:ext uri="{FF2B5EF4-FFF2-40B4-BE49-F238E27FC236}">
-                <a16:creationId xmlns:a16="http://schemas.microsoft.com/office/drawing/2014/main" id="{83498F14-0390-49F6-9FCC-FE623DF0CD06}"/>
+                <a16:creationId xmlns:a16="http://schemas.microsoft.com/office/drawing/2014/main" id="{7C9B61AE-C39A-4F2C-86BE-EE9DABEB894C}"/>
               </a:ext>
             </a:extLst>
           </p:cNvPr>
@@ -2624,7 +2624,7 @@
                   <a:srgbClr val="FFFFFF"/>
                 </a:solidFill>
               </a:rPr>
-              <a:t>下一步：以真实用户共创扩展个人终端中的高情绪决策场景</a:t>
+              <a:t>下一步：找真实用户试用，把对话做得更自然、更有用</a:t>
             </a:r>
           </a:p>
         </p:txBody>
@@ -2634,7 +2634,7 @@
           <p:cNvPr id="7" name="">
             <a:extLst xmlns:a="http://schemas.openxmlformats.org/drawingml/2006/main">
               <a:ext uri="{FF2B5EF4-FFF2-40B4-BE49-F238E27FC236}">
-                <a16:creationId xmlns:a16="http://schemas.microsoft.com/office/drawing/2014/main" id="{891CE28C-DF40-44F6-949A-11C2C408E749}"/>
+                <a16:creationId xmlns:a16="http://schemas.microsoft.com/office/drawing/2014/main" id="{81FCE5C0-5E8B-45FE-BC96-04D520BD4634}"/>
               </a:ext>
             </a:extLst>
           </p:cNvPr>
@@ -2684,7 +2684,7 @@
           <p:cNvPr id="8" name="">
             <a:extLst xmlns:a="http://schemas.openxmlformats.org/drawingml/2006/main">
               <a:ext uri="{FF2B5EF4-FFF2-40B4-BE49-F238E27FC236}">
-                <a16:creationId xmlns:a16="http://schemas.microsoft.com/office/drawing/2014/main" id="{2C395613-C411-4D11-AED2-3FCD85B3221E}"/>
+                <a16:creationId xmlns:a16="http://schemas.microsoft.com/office/drawing/2014/main" id="{ED2CA39A-7D43-41A4-ADDD-E23B3F4E4E86}"/>
               </a:ext>
             </a:extLst>
           </p:cNvPr>
@@ -2734,7 +2734,7 @@
           <p:cNvPr id="9" name="">
             <a:extLst xmlns:a="http://schemas.openxmlformats.org/drawingml/2006/main">
               <a:ext uri="{FF2B5EF4-FFF2-40B4-BE49-F238E27FC236}">
-                <a16:creationId xmlns:a16="http://schemas.microsoft.com/office/drawing/2014/main" id="{F9F62855-6A04-45EF-B36F-E4DA2076675E}"/>
+                <a16:creationId xmlns:a16="http://schemas.microsoft.com/office/drawing/2014/main" id="{1FBC485F-B44A-47DF-9EFA-BBD95370945F}"/>
               </a:ext>
             </a:extLst>
           </p:cNvPr>
@@ -2782,7 +2782,7 @@
     </p:spTree>
     <p:extLst>
       <p:ext uri="{BB962C8B-B14F-4D97-AF65-F5344CB8AC3E}">
-        <p14:creationId xmlns:p14="http://schemas.microsoft.com/office/powerpoint/2010/main" val="787051400"/>
+        <p14:creationId xmlns:p14="http://schemas.microsoft.com/office/powerpoint/2010/main" val="1921117819"/>
       </p:ext>
     </p:extLst>
   </p:cSld>
@@ -2813,7 +2813,7 @@
           <p:cNvPr id="12" name="">
             <a:extLst xmlns:a="http://schemas.openxmlformats.org/drawingml/2006/main">
               <a:ext uri="{FF2B5EF4-FFF2-40B4-BE49-F238E27FC236}">
-                <a16:creationId xmlns:a16="http://schemas.microsoft.com/office/drawing/2014/main" id="{52D6A8D9-A995-44F5-85EC-317603C13893}"/>
+                <a16:creationId xmlns:a16="http://schemas.microsoft.com/office/drawing/2014/main" id="{3780404C-D36C-4A43-ADBA-6AA09F56E775}"/>
               </a:ext>
             </a:extLst>
           </p:cNvPr>
@@ -2853,7 +2853,7 @@
                   <a:srgbClr val="FF168F"/>
                 </a:solidFill>
               </a:rPr>
-              <a:t>01 · PROBLEM</a:t>
+              <a:t>01 · 为什么需要它</a:t>
             </a:r>
           </a:p>
         </p:txBody>
@@ -2863,7 +2863,7 @@
           <p:cNvPr id="2" name="">
             <a:extLst xmlns:a="http://schemas.openxmlformats.org/drawingml/2006/main">
               <a:ext uri="{FF2B5EF4-FFF2-40B4-BE49-F238E27FC236}">
-                <a16:creationId xmlns:a16="http://schemas.microsoft.com/office/drawing/2014/main" id="{8EC1EC60-9216-408E-93F4-429D2CAD42C5}"/>
+                <a16:creationId xmlns:a16="http://schemas.microsoft.com/office/drawing/2014/main" id="{B324DF67-95A6-492B-AC40-EF039CAC86E9}"/>
               </a:ext>
             </a:extLst>
           </p:cNvPr>
@@ -2903,7 +2903,7 @@
                   <a:srgbClr val="25121D"/>
                 </a:solidFill>
               </a:rPr>
-              <a:t>关系建议的问题，不是“不会说”</a:t>
+              <a:t>感情问题最难的，不是“不会说”</a:t>
             </a:r>
           </a:p>
         </p:txBody>
@@ -2913,7 +2913,7 @@
           <p:cNvPr id="3" name="">
             <a:extLst xmlns:a="http://schemas.openxmlformats.org/drawingml/2006/main">
               <a:ext uri="{FF2B5EF4-FFF2-40B4-BE49-F238E27FC236}">
-                <a16:creationId xmlns:a16="http://schemas.microsoft.com/office/drawing/2014/main" id="{3D926748-1790-4B44-BC14-3C0350B632AC}"/>
+                <a16:creationId xmlns:a16="http://schemas.microsoft.com/office/drawing/2014/main" id="{98F989B5-8935-4CDB-947F-A58CD65746FF}"/>
               </a:ext>
             </a:extLst>
           </p:cNvPr>
@@ -2953,7 +2953,7 @@
                   <a:srgbClr val="765C6A"/>
                 </a:solidFill>
               </a:rPr>
-              <a:t>而是情绪、证据和行动混在一起，用户无法判断下一步。</a:t>
+              <a:t>而是心里很乱，分不清发生了什么，也不知道下一步该怎么做。</a:t>
             </a:r>
           </a:p>
         </p:txBody>
@@ -2963,7 +2963,7 @@
           <p:cNvPr id="4" name="">
             <a:extLst xmlns:a="http://schemas.openxmlformats.org/drawingml/2006/main">
               <a:ext uri="{FF2B5EF4-FFF2-40B4-BE49-F238E27FC236}">
-                <a16:creationId xmlns:a16="http://schemas.microsoft.com/office/drawing/2014/main" id="{EE819756-7928-4171-9E6E-42AC0F374328}"/>
+                <a16:creationId xmlns:a16="http://schemas.microsoft.com/office/drawing/2014/main" id="{F1A5A427-4822-4B0A-A220-A06DCD7A5F1D}"/>
               </a:ext>
             </a:extLst>
           </p:cNvPr>
@@ -3013,7 +3013,7 @@
           <p:cNvPr id="5" name="">
             <a:extLst xmlns:a="http://schemas.openxmlformats.org/drawingml/2006/main">
               <a:ext uri="{FF2B5EF4-FFF2-40B4-BE49-F238E27FC236}">
-                <a16:creationId xmlns:a16="http://schemas.microsoft.com/office/drawing/2014/main" id="{C22E1B8D-5918-479E-8AB9-8A79DB261BC8}"/>
+                <a16:creationId xmlns:a16="http://schemas.microsoft.com/office/drawing/2014/main" id="{4DC9ABA9-1B3E-43CA-BF58-5CE0EC88E90D}"/>
               </a:ext>
             </a:extLst>
           </p:cNvPr>
@@ -3063,7 +3063,7 @@
           <p:cNvPr id="6" name="">
             <a:extLst xmlns:a="http://schemas.openxmlformats.org/drawingml/2006/main">
               <a:ext uri="{FF2B5EF4-FFF2-40B4-BE49-F238E27FC236}">
-                <a16:creationId xmlns:a16="http://schemas.microsoft.com/office/drawing/2014/main" id="{E1E5A9A5-9991-4115-B635-13D335D82B35}"/>
+                <a16:creationId xmlns:a16="http://schemas.microsoft.com/office/drawing/2014/main" id="{5837EF4B-3193-4CB2-81FE-7EBF1E5A0BD2}"/>
               </a:ext>
             </a:extLst>
           </p:cNvPr>
@@ -3103,7 +3103,7 @@
                   <a:srgbClr val="310019"/>
                 </a:solidFill>
               </a:rPr>
-              <a:t>低确定性</a:t>
+              <a:t>看不清</a:t>
             </a:r>
           </a:p>
         </p:txBody>
@@ -3113,7 +3113,7 @@
           <p:cNvPr id="7" name="">
             <a:extLst xmlns:a="http://schemas.openxmlformats.org/drawingml/2006/main">
               <a:ext uri="{FF2B5EF4-FFF2-40B4-BE49-F238E27FC236}">
-                <a16:creationId xmlns:a16="http://schemas.microsoft.com/office/drawing/2014/main" id="{D10730E7-14B5-40A3-8CD2-F777CA7296F5}"/>
+                <a16:creationId xmlns:a16="http://schemas.microsoft.com/office/drawing/2014/main" id="{6636D0A5-2673-497A-A0A5-4B4FC22CBC14}"/>
               </a:ext>
             </a:extLst>
           </p:cNvPr>
@@ -3153,7 +3153,7 @@
                   <a:srgbClr val="25121D"/>
                 </a:solidFill>
               </a:rPr>
-              <a:t>建议看似正确，却没有证据来源、观察窗口和停止条件。</a:t>
+              <a:t>建议听起来有道理，却不知道该信什么、等多久、什么时候该停。</a:t>
             </a:r>
           </a:p>
         </p:txBody>
@@ -3163,7 +3163,7 @@
           <p:cNvPr id="8" name="">
             <a:extLst xmlns:a="http://schemas.openxmlformats.org/drawingml/2006/main">
               <a:ext uri="{FF2B5EF4-FFF2-40B4-BE49-F238E27FC236}">
-                <a16:creationId xmlns:a16="http://schemas.microsoft.com/office/drawing/2014/main" id="{D0EAD1ED-D3B0-44EE-93A6-645153B37914}"/>
+                <a16:creationId xmlns:a16="http://schemas.microsoft.com/office/drawing/2014/main" id="{5B7B3D8E-FB01-4B05-AEF2-5685A91B1443}"/>
               </a:ext>
             </a:extLst>
           </p:cNvPr>
@@ -3202,7 +3202,7 @@
           <p:nvPr/>
         </p:nvPicPr>
         <p:blipFill>
-          <a:blip xmlns:r="http://schemas.openxmlformats.org/officeDocument/2006/relationships" xmlns:a="http://schemas.openxmlformats.org/drawingml/2006/main" r:embed="R01b6ada6b05944d5"/>
+          <a:blip xmlns:r="http://schemas.openxmlformats.org/officeDocument/2006/relationships" xmlns:a="http://schemas.openxmlformats.org/drawingml/2006/main" r:embed="Rdaac66c442004fdd"/>
           <a:srcRect xmlns:a="http://schemas.openxmlformats.org/drawingml/2006/main" l="70" t="0" r="70" b="0"/>
           <a:stretch xmlns:a="http://schemas.openxmlformats.org/drawingml/2006/main">
             <a:fillRect l="0" t="0" r="0" b="0"/>
@@ -3225,7 +3225,7 @@
           <p:cNvPr id="10" name="">
             <a:extLst xmlns:a="http://schemas.openxmlformats.org/drawingml/2006/main">
               <a:ext uri="{FF2B5EF4-FFF2-40B4-BE49-F238E27FC236}">
-                <a16:creationId xmlns:a16="http://schemas.microsoft.com/office/drawing/2014/main" id="{7B485B75-42E2-47E1-8C15-64D63E0B9CF7}"/>
+                <a16:creationId xmlns:a16="http://schemas.microsoft.com/office/drawing/2014/main" id="{72303EE7-02D6-4119-9A0A-0ED3C36FF771}"/>
               </a:ext>
             </a:extLst>
           </p:cNvPr>
@@ -3275,7 +3275,7 @@
           <p:cNvPr id="11" name="">
             <a:extLst xmlns:a="http://schemas.openxmlformats.org/drawingml/2006/main">
               <a:ext uri="{FF2B5EF4-FFF2-40B4-BE49-F238E27FC236}">
-                <a16:creationId xmlns:a16="http://schemas.microsoft.com/office/drawing/2014/main" id="{83B5B838-805C-4202-B0B1-309C73396265}"/>
+                <a16:creationId xmlns:a16="http://schemas.microsoft.com/office/drawing/2014/main" id="{41DB2E10-4187-486E-BE5E-B077E2A28C98}"/>
               </a:ext>
             </a:extLst>
           </p:cNvPr>
@@ -3323,7 +3323,7 @@
     </p:spTree>
     <p:extLst>
       <p:ext uri="{BB962C8B-B14F-4D97-AF65-F5344CB8AC3E}">
-        <p14:creationId xmlns:p14="http://schemas.microsoft.com/office/powerpoint/2010/main" val="1741200949"/>
+        <p14:creationId xmlns:p14="http://schemas.microsoft.com/office/powerpoint/2010/main" val="868224373"/>
       </p:ext>
     </p:extLst>
   </p:cSld>
@@ -3354,7 +3354,7 @@
           <p:cNvPr id="31" name="">
             <a:extLst xmlns:a="http://schemas.openxmlformats.org/drawingml/2006/main">
               <a:ext uri="{FF2B5EF4-FFF2-40B4-BE49-F238E27FC236}">
-                <a16:creationId xmlns:a16="http://schemas.microsoft.com/office/drawing/2014/main" id="{4DF0373B-BA0E-47D2-9B6C-98D8F5C4E875}"/>
+                <a16:creationId xmlns:a16="http://schemas.microsoft.com/office/drawing/2014/main" id="{1E2C056C-70BA-486D-A070-92D93ABEDC62}"/>
               </a:ext>
             </a:extLst>
           </p:cNvPr>
@@ -3394,7 +3394,7 @@
                   <a:srgbClr val="FF168F"/>
                 </a:solidFill>
               </a:rPr>
-              <a:t>02 · SOLUTION</a:t>
+              <a:t>02 · 它怎么帮你</a:t>
             </a:r>
           </a:p>
         </p:txBody>
@@ -3404,7 +3404,7 @@
           <p:cNvPr id="2" name="">
             <a:extLst xmlns:a="http://schemas.openxmlformats.org/drawingml/2006/main">
               <a:ext uri="{FF2B5EF4-FFF2-40B4-BE49-F238E27FC236}">
-                <a16:creationId xmlns:a16="http://schemas.microsoft.com/office/drawing/2014/main" id="{6CC6AAA8-2633-4D9E-8476-A77AB9762811}"/>
+                <a16:creationId xmlns:a16="http://schemas.microsoft.com/office/drawing/2014/main" id="{BC63A585-5C05-49CE-A96A-0D29F4EC50D8}"/>
               </a:ext>
             </a:extLst>
           </p:cNvPr>
@@ -3444,7 +3444,7 @@
                   <a:srgbClr val="FFFFFF"/>
                 </a:solidFill>
               </a:rPr>
-              <a:t>把一次咨询变成可验证的决策闭环</a:t>
+              <a:t>从“我好乱”走到“下一步怎么做”</a:t>
             </a:r>
           </a:p>
         </p:txBody>
@@ -3454,7 +3454,7 @@
           <p:cNvPr id="3" name="">
             <a:extLst xmlns:a="http://schemas.openxmlformats.org/drawingml/2006/main">
               <a:ext uri="{FF2B5EF4-FFF2-40B4-BE49-F238E27FC236}">
-                <a16:creationId xmlns:a16="http://schemas.microsoft.com/office/drawing/2014/main" id="{2969389A-FE16-4526-9622-31E4075BC7AD}"/>
+                <a16:creationId xmlns:a16="http://schemas.microsoft.com/office/drawing/2014/main" id="{4E236008-7F0B-478D-B9E1-1798E440CE04}"/>
               </a:ext>
             </a:extLst>
           </p:cNvPr>
@@ -3494,7 +3494,7 @@
                   <a:srgbClr val="E9CAD9"/>
                 </a:solidFill>
               </a:rPr>
-              <a:t>Agent 不替用户猜答案，只帮助用户做出下一步可观察的选择。</a:t>
+              <a:t>每次都说清楚：现在知道什么、接下来做什么、多久后看结果、什么时候该停。</a:t>
             </a:r>
           </a:p>
         </p:txBody>
@@ -3504,7 +3504,7 @@
           <p:cNvPr id="4" name="">
             <a:extLst xmlns:a="http://schemas.openxmlformats.org/drawingml/2006/main">
               <a:ext uri="{FF2B5EF4-FFF2-40B4-BE49-F238E27FC236}">
-                <a16:creationId xmlns:a16="http://schemas.microsoft.com/office/drawing/2014/main" id="{47391858-C5C4-481F-8DF4-E93C93A7376B}"/>
+                <a16:creationId xmlns:a16="http://schemas.microsoft.com/office/drawing/2014/main" id="{E80EE75F-623C-435B-B063-09FA17B7A53F}"/>
               </a:ext>
             </a:extLst>
           </p:cNvPr>
@@ -3537,7 +3537,7 @@
           <p:cNvPr id="5" name="">
             <a:extLst xmlns:a="http://schemas.openxmlformats.org/drawingml/2006/main">
               <a:ext uri="{FF2B5EF4-FFF2-40B4-BE49-F238E27FC236}">
-                <a16:creationId xmlns:a16="http://schemas.microsoft.com/office/drawing/2014/main" id="{64C5CF32-F96D-4E54-9829-4FCE7EAD181C}"/>
+                <a16:creationId xmlns:a16="http://schemas.microsoft.com/office/drawing/2014/main" id="{DE361A8C-B523-45C2-9A84-395FED692A0D}"/>
               </a:ext>
             </a:extLst>
           </p:cNvPr>
@@ -3572,7 +3572,7 @@
           <p:cNvPr id="6" name="">
             <a:extLst xmlns:a="http://schemas.openxmlformats.org/drawingml/2006/main">
               <a:ext uri="{FF2B5EF4-FFF2-40B4-BE49-F238E27FC236}">
-                <a16:creationId xmlns:a16="http://schemas.microsoft.com/office/drawing/2014/main" id="{FD1EA651-37F5-4217-8F66-BE971EFEA3E3}"/>
+                <a16:creationId xmlns:a16="http://schemas.microsoft.com/office/drawing/2014/main" id="{022C7399-F0FF-42BE-99BF-A9F0C4F806BF}"/>
               </a:ext>
             </a:extLst>
           </p:cNvPr>
@@ -3622,7 +3622,7 @@
           <p:cNvPr id="7" name="">
             <a:extLst xmlns:a="http://schemas.openxmlformats.org/drawingml/2006/main">
               <a:ext uri="{FF2B5EF4-FFF2-40B4-BE49-F238E27FC236}">
-                <a16:creationId xmlns:a16="http://schemas.microsoft.com/office/drawing/2014/main" id="{DE2BDB08-AC6B-4BD4-86FC-D2267DF60ACF}"/>
+                <a16:creationId xmlns:a16="http://schemas.microsoft.com/office/drawing/2014/main" id="{047B15F1-49B1-4B7A-BCB3-74439DE78993}"/>
               </a:ext>
             </a:extLst>
           </p:cNvPr>
@@ -3662,7 +3662,7 @@
                   <a:srgbClr val="FFFFFF"/>
                 </a:solidFill>
               </a:rPr>
-              <a:t>承接情绪</a:t>
+              <a:t>先听你说</a:t>
             </a:r>
           </a:p>
         </p:txBody>
@@ -3672,7 +3672,7 @@
           <p:cNvPr id="8" name="">
             <a:extLst xmlns:a="http://schemas.openxmlformats.org/drawingml/2006/main">
               <a:ext uri="{FF2B5EF4-FFF2-40B4-BE49-F238E27FC236}">
-                <a16:creationId xmlns:a16="http://schemas.microsoft.com/office/drawing/2014/main" id="{BD380714-EB29-4B50-A94B-006FAC8C93BA}"/>
+                <a16:creationId xmlns:a16="http://schemas.microsoft.com/office/drawing/2014/main" id="{E43F6E75-B120-4CC2-9CF3-F9EA4DCD18FF}"/>
               </a:ext>
             </a:extLst>
           </p:cNvPr>
@@ -3712,7 +3712,7 @@
                   <a:srgbClr val="DFBFD0"/>
                 </a:solidFill>
               </a:rPr>
-              <a:t>先听懂用户在怕什么</a:t>
+              <a:t>听懂你最难受、最担心什么</a:t>
             </a:r>
           </a:p>
         </p:txBody>
@@ -3722,7 +3722,7 @@
           <p:cNvPr id="9" name="">
             <a:extLst xmlns:a="http://schemas.openxmlformats.org/drawingml/2006/main">
               <a:ext uri="{FF2B5EF4-FFF2-40B4-BE49-F238E27FC236}">
-                <a16:creationId xmlns:a16="http://schemas.microsoft.com/office/drawing/2014/main" id="{FA525FAE-B700-4AAF-B92E-8CD0AC707F89}"/>
+                <a16:creationId xmlns:a16="http://schemas.microsoft.com/office/drawing/2014/main" id="{88857082-D9BD-4D77-AB86-FC2684EBA08B}"/>
               </a:ext>
             </a:extLst>
           </p:cNvPr>
@@ -3757,7 +3757,7 @@
           <p:cNvPr id="10" name="">
             <a:extLst xmlns:a="http://schemas.openxmlformats.org/drawingml/2006/main">
               <a:ext uri="{FF2B5EF4-FFF2-40B4-BE49-F238E27FC236}">
-                <a16:creationId xmlns:a16="http://schemas.microsoft.com/office/drawing/2014/main" id="{C6DEEFA1-1373-49F2-BFA6-2B683CD94F85}"/>
+                <a16:creationId xmlns:a16="http://schemas.microsoft.com/office/drawing/2014/main" id="{E7C68DB1-8CFC-4DAF-8496-04A03A56274B}"/>
               </a:ext>
             </a:extLst>
           </p:cNvPr>
@@ -3807,7 +3807,7 @@
           <p:cNvPr id="11" name="">
             <a:extLst xmlns:a="http://schemas.openxmlformats.org/drawingml/2006/main">
               <a:ext uri="{FF2B5EF4-FFF2-40B4-BE49-F238E27FC236}">
-                <a16:creationId xmlns:a16="http://schemas.microsoft.com/office/drawing/2014/main" id="{27A52907-F62D-4B3E-A5C6-FEB157D358A4}"/>
+                <a16:creationId xmlns:a16="http://schemas.microsoft.com/office/drawing/2014/main" id="{D0D93BC8-1F7F-416E-BD29-0C4F674B8B51}"/>
               </a:ext>
             </a:extLst>
           </p:cNvPr>
@@ -3847,7 +3847,7 @@
                   <a:srgbClr val="FFFFFF"/>
                 </a:solidFill>
               </a:rPr>
-              <a:t>拆分证据</a:t>
+              <a:t>分清楚</a:t>
             </a:r>
           </a:p>
         </p:txBody>
@@ -3857,7 +3857,7 @@
           <p:cNvPr id="12" name="">
             <a:extLst xmlns:a="http://schemas.openxmlformats.org/drawingml/2006/main">
               <a:ext uri="{FF2B5EF4-FFF2-40B4-BE49-F238E27FC236}">
-                <a16:creationId xmlns:a16="http://schemas.microsoft.com/office/drawing/2014/main" id="{4018325C-EBEF-454E-9ECE-8721DADC639D}"/>
+                <a16:creationId xmlns:a16="http://schemas.microsoft.com/office/drawing/2014/main" id="{CF8B64E3-4DE4-4416-83A9-B0F12B8E9F25}"/>
               </a:ext>
             </a:extLst>
           </p:cNvPr>
@@ -3897,7 +3897,7 @@
                   <a:srgbClr val="DFBFD0"/>
                 </a:solidFill>
               </a:rPr>
-              <a:t>事实 / 推测 / 未知</a:t>
+              <a:t>哪些是真的，哪些是猜的</a:t>
             </a:r>
           </a:p>
         </p:txBody>
@@ -3907,7 +3907,7 @@
           <p:cNvPr id="13" name="">
             <a:extLst xmlns:a="http://schemas.openxmlformats.org/drawingml/2006/main">
               <a:ext uri="{FF2B5EF4-FFF2-40B4-BE49-F238E27FC236}">
-                <a16:creationId xmlns:a16="http://schemas.microsoft.com/office/drawing/2014/main" id="{21D9C76E-8148-4173-98BA-38BB3D0CF190}"/>
+                <a16:creationId xmlns:a16="http://schemas.microsoft.com/office/drawing/2014/main" id="{1E5F23C1-B8E4-4658-BEBA-5E73C7D431D0}"/>
               </a:ext>
             </a:extLst>
           </p:cNvPr>
@@ -3942,7 +3942,7 @@
           <p:cNvPr id="14" name="">
             <a:extLst xmlns:a="http://schemas.openxmlformats.org/drawingml/2006/main">
               <a:ext uri="{FF2B5EF4-FFF2-40B4-BE49-F238E27FC236}">
-                <a16:creationId xmlns:a16="http://schemas.microsoft.com/office/drawing/2014/main" id="{EA7C4F8E-42B4-4163-8135-928DC0233D4B}"/>
+                <a16:creationId xmlns:a16="http://schemas.microsoft.com/office/drawing/2014/main" id="{3FA060F8-D1BC-4AF3-B185-ABE68323D8F6}"/>
               </a:ext>
             </a:extLst>
           </p:cNvPr>
@@ -3992,7 +3992,7 @@
           <p:cNvPr id="15" name="">
             <a:extLst xmlns:a="http://schemas.openxmlformats.org/drawingml/2006/main">
               <a:ext uri="{FF2B5EF4-FFF2-40B4-BE49-F238E27FC236}">
-                <a16:creationId xmlns:a16="http://schemas.microsoft.com/office/drawing/2014/main" id="{70BF8B8F-ACFF-452F-82F0-5D6AA4B531C4}"/>
+                <a16:creationId xmlns:a16="http://schemas.microsoft.com/office/drawing/2014/main" id="{261C292E-C4A7-436A-A943-E09237E67AB3}"/>
               </a:ext>
             </a:extLst>
           </p:cNvPr>
@@ -4032,7 +4032,7 @@
                   <a:srgbClr val="FFFFFF"/>
                 </a:solidFill>
               </a:rPr>
-              <a:t>选择方向</a:t>
+              <a:t>选下一步</a:t>
             </a:r>
           </a:p>
         </p:txBody>
@@ -4042,7 +4042,7 @@
           <p:cNvPr id="16" name="">
             <a:extLst xmlns:a="http://schemas.openxmlformats.org/drawingml/2006/main">
               <a:ext uri="{FF2B5EF4-FFF2-40B4-BE49-F238E27FC236}">
-                <a16:creationId xmlns:a16="http://schemas.microsoft.com/office/drawing/2014/main" id="{D8F57C8A-1A25-4C14-8AD4-2CA1A9F06296}"/>
+                <a16:creationId xmlns:a16="http://schemas.microsoft.com/office/drawing/2014/main" id="{9976F173-E26C-4406-A0F6-096E14217613}"/>
               </a:ext>
             </a:extLst>
           </p:cNvPr>
@@ -4082,7 +4082,7 @@
                   <a:srgbClr val="DFBFD0"/>
                 </a:solidFill>
               </a:rPr>
-              <a:t>推进 / 确认 / 修复 / 退出</a:t>
+              <a:t>继续 / 问清 / 修复 / 离开</a:t>
             </a:r>
           </a:p>
         </p:txBody>
@@ -4092,7 +4092,7 @@
           <p:cNvPr id="17" name="">
             <a:extLst xmlns:a="http://schemas.openxmlformats.org/drawingml/2006/main">
               <a:ext uri="{FF2B5EF4-FFF2-40B4-BE49-F238E27FC236}">
-                <a16:creationId xmlns:a16="http://schemas.microsoft.com/office/drawing/2014/main" id="{84EABBF2-D90E-4392-8F85-716EFA09C716}"/>
+                <a16:creationId xmlns:a16="http://schemas.microsoft.com/office/drawing/2014/main" id="{29804055-86D8-49D9-9027-A05358690CBD}"/>
               </a:ext>
             </a:extLst>
           </p:cNvPr>
@@ -4127,7 +4127,7 @@
           <p:cNvPr id="18" name="">
             <a:extLst xmlns:a="http://schemas.openxmlformats.org/drawingml/2006/main">
               <a:ext uri="{FF2B5EF4-FFF2-40B4-BE49-F238E27FC236}">
-                <a16:creationId xmlns:a16="http://schemas.microsoft.com/office/drawing/2014/main" id="{904BE2E2-03D6-413E-82F2-B1D2D4BADCA3}"/>
+                <a16:creationId xmlns:a16="http://schemas.microsoft.com/office/drawing/2014/main" id="{C194C9C3-03CB-4552-8233-88F8914AF7DD}"/>
               </a:ext>
             </a:extLst>
           </p:cNvPr>
@@ -4177,7 +4177,7 @@
           <p:cNvPr id="19" name="">
             <a:extLst xmlns:a="http://schemas.openxmlformats.org/drawingml/2006/main">
               <a:ext uri="{FF2B5EF4-FFF2-40B4-BE49-F238E27FC236}">
-                <a16:creationId xmlns:a16="http://schemas.microsoft.com/office/drawing/2014/main" id="{BACBB714-6C86-49AE-8429-03D864FE8C31}"/>
+                <a16:creationId xmlns:a16="http://schemas.microsoft.com/office/drawing/2014/main" id="{BD8CE522-8DE7-4924-93F6-F4D487E66470}"/>
               </a:ext>
             </a:extLst>
           </p:cNvPr>
@@ -4217,7 +4217,7 @@
                   <a:srgbClr val="FFFFFF"/>
                 </a:solidFill>
               </a:rPr>
-              <a:t>生成行动</a:t>
+              <a:t>给你一句话</a:t>
             </a:r>
           </a:p>
         </p:txBody>
@@ -4227,7 +4227,7 @@
           <p:cNvPr id="20" name="">
             <a:extLst xmlns:a="http://schemas.openxmlformats.org/drawingml/2006/main">
               <a:ext uri="{FF2B5EF4-FFF2-40B4-BE49-F238E27FC236}">
-                <a16:creationId xmlns:a16="http://schemas.microsoft.com/office/drawing/2014/main" id="{66047D9B-7044-4AD1-928A-8CD130CB001A}"/>
+                <a16:creationId xmlns:a16="http://schemas.microsoft.com/office/drawing/2014/main" id="{E1F216F2-F70C-4388-A85B-B139DDC93B48}"/>
               </a:ext>
             </a:extLst>
           </p:cNvPr>
@@ -4267,7 +4267,7 @@
                   <a:srgbClr val="DFBFD0"/>
                 </a:solidFill>
               </a:rPr>
-              <a:t>可复制话术</a:t>
+              <a:t>可以直接复制，也可以自己改</a:t>
             </a:r>
           </a:p>
         </p:txBody>
@@ -4277,7 +4277,7 @@
           <p:cNvPr id="21" name="">
             <a:extLst xmlns:a="http://schemas.openxmlformats.org/drawingml/2006/main">
               <a:ext uri="{FF2B5EF4-FFF2-40B4-BE49-F238E27FC236}">
-                <a16:creationId xmlns:a16="http://schemas.microsoft.com/office/drawing/2014/main" id="{0835CBFD-A201-41E5-AFDF-47DBA6006A71}"/>
+                <a16:creationId xmlns:a16="http://schemas.microsoft.com/office/drawing/2014/main" id="{40ED31D5-2352-4EDC-90B6-4F5ECF3C87B6}"/>
               </a:ext>
             </a:extLst>
           </p:cNvPr>
@@ -4312,7 +4312,7 @@
           <p:cNvPr id="22" name="">
             <a:extLst xmlns:a="http://schemas.openxmlformats.org/drawingml/2006/main">
               <a:ext uri="{FF2B5EF4-FFF2-40B4-BE49-F238E27FC236}">
-                <a16:creationId xmlns:a16="http://schemas.microsoft.com/office/drawing/2014/main" id="{DFB8382F-FBFB-42CA-9BD5-92646B0FA755}"/>
+                <a16:creationId xmlns:a16="http://schemas.microsoft.com/office/drawing/2014/main" id="{CDD95551-923D-4F02-BDA2-A12D4D99606D}"/>
               </a:ext>
             </a:extLst>
           </p:cNvPr>
@@ -4362,7 +4362,7 @@
           <p:cNvPr id="23" name="">
             <a:extLst xmlns:a="http://schemas.openxmlformats.org/drawingml/2006/main">
               <a:ext uri="{FF2B5EF4-FFF2-40B4-BE49-F238E27FC236}">
-                <a16:creationId xmlns:a16="http://schemas.microsoft.com/office/drawing/2014/main" id="{22138137-3004-4449-8470-C3D74FD68B3B}"/>
+                <a16:creationId xmlns:a16="http://schemas.microsoft.com/office/drawing/2014/main" id="{563F9F86-D451-4141-83EC-DC77554D93B5}"/>
               </a:ext>
             </a:extLst>
           </p:cNvPr>
@@ -4402,7 +4402,7 @@
                   <a:srgbClr val="FFFFFF"/>
                 </a:solidFill>
               </a:rPr>
-              <a:t>定义观察</a:t>
+              <a:t>约好看多久</a:t>
             </a:r>
           </a:p>
         </p:txBody>
@@ -4412,7 +4412,7 @@
           <p:cNvPr id="24" name="">
             <a:extLst xmlns:a="http://schemas.openxmlformats.org/drawingml/2006/main">
               <a:ext uri="{FF2B5EF4-FFF2-40B4-BE49-F238E27FC236}">
-                <a16:creationId xmlns:a16="http://schemas.microsoft.com/office/drawing/2014/main" id="{7C84FC47-35B0-47AA-A88C-ED93212531D9}"/>
+                <a16:creationId xmlns:a16="http://schemas.microsoft.com/office/drawing/2014/main" id="{D7BAAB91-635A-4849-9C58-EC41D1060352}"/>
               </a:ext>
             </a:extLst>
           </p:cNvPr>
@@ -4452,7 +4452,7 @@
                   <a:srgbClr val="DFBFD0"/>
                 </a:solidFill>
               </a:rPr>
-              <a:t>时间窗口 + 停止条件</a:t>
+              <a:t>等多久、看什么、何时停</a:t>
             </a:r>
           </a:p>
         </p:txBody>
@@ -4462,7 +4462,7 @@
           <p:cNvPr id="25" name="">
             <a:extLst xmlns:a="http://schemas.openxmlformats.org/drawingml/2006/main">
               <a:ext uri="{FF2B5EF4-FFF2-40B4-BE49-F238E27FC236}">
-                <a16:creationId xmlns:a16="http://schemas.microsoft.com/office/drawing/2014/main" id="{34EB3D92-1E0B-41A3-98B1-7FD4D450B7EE}"/>
+                <a16:creationId xmlns:a16="http://schemas.microsoft.com/office/drawing/2014/main" id="{434FB554-6570-4F46-BD57-FFF9F8E48181}"/>
               </a:ext>
             </a:extLst>
           </p:cNvPr>
@@ -4497,7 +4497,7 @@
           <p:cNvPr id="26" name="">
             <a:extLst xmlns:a="http://schemas.openxmlformats.org/drawingml/2006/main">
               <a:ext uri="{FF2B5EF4-FFF2-40B4-BE49-F238E27FC236}">
-                <a16:creationId xmlns:a16="http://schemas.microsoft.com/office/drawing/2014/main" id="{39379E27-0717-46B1-9547-9A8D84FD9C83}"/>
+                <a16:creationId xmlns:a16="http://schemas.microsoft.com/office/drawing/2014/main" id="{880CB7E7-2C9C-4510-9A9C-A6683396EF5F}"/>
               </a:ext>
             </a:extLst>
           </p:cNvPr>
@@ -4547,7 +4547,7 @@
           <p:cNvPr id="27" name="">
             <a:extLst xmlns:a="http://schemas.openxmlformats.org/drawingml/2006/main">
               <a:ext uri="{FF2B5EF4-FFF2-40B4-BE49-F238E27FC236}">
-                <a16:creationId xmlns:a16="http://schemas.microsoft.com/office/drawing/2014/main" id="{973C806F-D320-472D-91EB-537A542B7C2B}"/>
+                <a16:creationId xmlns:a16="http://schemas.microsoft.com/office/drawing/2014/main" id="{73A15355-14EF-4919-AC97-0848BFD9E41F}"/>
               </a:ext>
             </a:extLst>
           </p:cNvPr>
@@ -4587,7 +4587,7 @@
                   <a:srgbClr val="FFFFFF"/>
                 </a:solidFill>
               </a:rPr>
-              <a:t>人工确认</a:t>
+              <a:t>你来决定</a:t>
             </a:r>
           </a:p>
         </p:txBody>
@@ -4597,7 +4597,7 @@
           <p:cNvPr id="28" name="">
             <a:extLst xmlns:a="http://schemas.openxmlformats.org/drawingml/2006/main">
               <a:ext uri="{FF2B5EF4-FFF2-40B4-BE49-F238E27FC236}">
-                <a16:creationId xmlns:a16="http://schemas.microsoft.com/office/drawing/2014/main" id="{C320BE62-29F1-4167-8002-BAA62FB71E24}"/>
+                <a16:creationId xmlns:a16="http://schemas.microsoft.com/office/drawing/2014/main" id="{AFA95472-95A9-4275-90B0-5167F6EC443E}"/>
               </a:ext>
             </a:extLst>
           </p:cNvPr>
@@ -4637,7 +4637,7 @@
                   <a:srgbClr val="FFFFFF"/>
                 </a:solidFill>
               </a:rPr>
-              <a:t>不自动发送消息</a:t>
+              <a:t>系统不替你发消息</a:t>
             </a:r>
           </a:p>
         </p:txBody>
@@ -4647,7 +4647,7 @@
           <p:cNvPr id="29" name="">
             <a:extLst xmlns:a="http://schemas.openxmlformats.org/drawingml/2006/main">
               <a:ext uri="{FF2B5EF4-FFF2-40B4-BE49-F238E27FC236}">
-                <a16:creationId xmlns:a16="http://schemas.microsoft.com/office/drawing/2014/main" id="{815674C4-8AB0-4504-AAA0-61E704541752}"/>
+                <a16:creationId xmlns:a16="http://schemas.microsoft.com/office/drawing/2014/main" id="{95AC8DA2-E052-433A-812D-64710A306B98}"/>
               </a:ext>
             </a:extLst>
           </p:cNvPr>
@@ -4697,7 +4697,7 @@
           <p:cNvPr id="30" name="">
             <a:extLst xmlns:a="http://schemas.openxmlformats.org/drawingml/2006/main">
               <a:ext uri="{FF2B5EF4-FFF2-40B4-BE49-F238E27FC236}">
-                <a16:creationId xmlns:a16="http://schemas.microsoft.com/office/drawing/2014/main" id="{6E2AAEE6-BDA5-4765-BAC2-748730F01F67}"/>
+                <a16:creationId xmlns:a16="http://schemas.microsoft.com/office/drawing/2014/main" id="{B5C38006-0158-4D69-8315-529804AA4B1B}"/>
               </a:ext>
             </a:extLst>
           </p:cNvPr>
@@ -4745,7 +4745,7 @@
     </p:spTree>
     <p:extLst>
       <p:ext uri="{BB962C8B-B14F-4D97-AF65-F5344CB8AC3E}">
-        <p14:creationId xmlns:p14="http://schemas.microsoft.com/office/powerpoint/2010/main" val="83943120"/>
+        <p14:creationId xmlns:p14="http://schemas.microsoft.com/office/powerpoint/2010/main" val="2080084423"/>
       </p:ext>
     </p:extLst>
   </p:cSld>
@@ -4776,7 +4776,7 @@
           <p:cNvPr id="13" name="">
             <a:extLst xmlns:a="http://schemas.openxmlformats.org/drawingml/2006/main">
               <a:ext uri="{FF2B5EF4-FFF2-40B4-BE49-F238E27FC236}">
-                <a16:creationId xmlns:a16="http://schemas.microsoft.com/office/drawing/2014/main" id="{0E0E2180-32F8-4DFD-8C9C-C9E160635C0B}"/>
+                <a16:creationId xmlns:a16="http://schemas.microsoft.com/office/drawing/2014/main" id="{AF3F640D-430B-49C8-BF0F-4994EB1108D3}"/>
               </a:ext>
             </a:extLst>
           </p:cNvPr>
@@ -4816,7 +4816,7 @@
                   <a:srgbClr val="FF168F"/>
                 </a:solidFill>
               </a:rPr>
-              <a:t>03 · EXPERIENCE</a:t>
+              <a:t>03 · 用起来什么感觉</a:t>
             </a:r>
           </a:p>
         </p:txBody>
@@ -4826,7 +4826,7 @@
           <p:cNvPr id="2" name="">
             <a:extLst xmlns:a="http://schemas.openxmlformats.org/drawingml/2006/main">
               <a:ext uri="{FF2B5EF4-FFF2-40B4-BE49-F238E27FC236}">
-                <a16:creationId xmlns:a16="http://schemas.microsoft.com/office/drawing/2014/main" id="{AD6820A5-8001-4039-868F-096AE9B623AE}"/>
+                <a16:creationId xmlns:a16="http://schemas.microsoft.com/office/drawing/2014/main" id="{B769A898-3251-4845-9FB2-BC8539E6BF60}"/>
               </a:ext>
             </a:extLst>
           </p:cNvPr>
@@ -4866,7 +4866,7 @@
                   <a:srgbClr val="25121D"/>
                 </a:solidFill>
               </a:rPr>
-              <a:t>核心体验仍然是一场正常对话</a:t>
+              <a:t>聊天要像聊天，不像做题</a:t>
             </a:r>
           </a:p>
         </p:txBody>
@@ -4876,7 +4876,7 @@
           <p:cNvPr id="3" name="">
             <a:extLst xmlns:a="http://schemas.openxmlformats.org/drawingml/2006/main">
               <a:ext uri="{FF2B5EF4-FFF2-40B4-BE49-F238E27FC236}">
-                <a16:creationId xmlns:a16="http://schemas.microsoft.com/office/drawing/2014/main" id="{3B3CBA0C-E0E0-4EC9-BA29-0645871D2F5D}"/>
+                <a16:creationId xmlns:a16="http://schemas.microsoft.com/office/drawing/2014/main" id="{AD97447F-173A-4BE7-AA58-DA4A5DFA33B0}"/>
               </a:ext>
             </a:extLst>
           </p:cNvPr>
@@ -4916,7 +4916,7 @@
                   <a:srgbClr val="765C6A"/>
                 </a:solidFill>
               </a:rPr>
-              <a:t>分析结构藏在 Agent 的判断里，用户看到的是自然承接与明确下一步。</a:t>
+              <a:t>复杂的判断放在背后，用户看到的是自然回应和清楚的下一步。</a:t>
             </a:r>
           </a:p>
         </p:txBody>
@@ -4926,7 +4926,7 @@
           <p:cNvPr id="4" name="">
             <a:extLst xmlns:a="http://schemas.openxmlformats.org/drawingml/2006/main">
               <a:ext uri="{FF2B5EF4-FFF2-40B4-BE49-F238E27FC236}">
-                <a16:creationId xmlns:a16="http://schemas.microsoft.com/office/drawing/2014/main" id="{33D93560-528B-4554-ACCB-B400ADAC367D}"/>
+                <a16:creationId xmlns:a16="http://schemas.microsoft.com/office/drawing/2014/main" id="{B332BB1A-F1F3-4015-9D17-1738731EE1A5}"/>
               </a:ext>
             </a:extLst>
           </p:cNvPr>
@@ -4965,7 +4965,7 @@
           <p:nvPr/>
         </p:nvPicPr>
         <p:blipFill>
-          <a:blip xmlns:r="http://schemas.openxmlformats.org/officeDocument/2006/relationships" xmlns:a="http://schemas.openxmlformats.org/drawingml/2006/main" r:embed="R7afc189240a4431b"/>
+          <a:blip xmlns:r="http://schemas.openxmlformats.org/officeDocument/2006/relationships" xmlns:a="http://schemas.openxmlformats.org/drawingml/2006/main" r:embed="R4f516817a31949ca"/>
           <a:srcRect xmlns:a="http://schemas.openxmlformats.org/drawingml/2006/main" l="0" t="7672" r="0" b="7672"/>
           <a:stretch xmlns:a="http://schemas.openxmlformats.org/drawingml/2006/main">
             <a:fillRect l="0" t="0" r="0" b="0"/>
@@ -4988,7 +4988,7 @@
           <p:cNvPr id="6" name="">
             <a:extLst xmlns:a="http://schemas.openxmlformats.org/drawingml/2006/main">
               <a:ext uri="{FF2B5EF4-FFF2-40B4-BE49-F238E27FC236}">
-                <a16:creationId xmlns:a16="http://schemas.microsoft.com/office/drawing/2014/main" id="{7E9ADD3E-C6A4-4C5B-B16E-FA2F77C69F1A}"/>
+                <a16:creationId xmlns:a16="http://schemas.microsoft.com/office/drawing/2014/main" id="{C9900332-5557-46F7-AADD-9767E1509469}"/>
               </a:ext>
             </a:extLst>
           </p:cNvPr>
@@ -5028,7 +5028,7 @@
                   <a:srgbClr val="FF168F"/>
                 </a:solidFill>
               </a:rPr>
-              <a:t>情绪先被接住</a:t>
+              <a:t>先听你说完</a:t>
             </a:r>
           </a:p>
         </p:txBody>
@@ -5038,7 +5038,7 @@
           <p:cNvPr id="7" name="">
             <a:extLst xmlns:a="http://schemas.openxmlformats.org/drawingml/2006/main">
               <a:ext uri="{FF2B5EF4-FFF2-40B4-BE49-F238E27FC236}">
-                <a16:creationId xmlns:a16="http://schemas.microsoft.com/office/drawing/2014/main" id="{6020781C-7A75-4E03-A4FF-B625B2A7FDAD}"/>
+                <a16:creationId xmlns:a16="http://schemas.microsoft.com/office/drawing/2014/main" id="{2B0753B3-0D11-401B-ADA6-D85B7B56E133}"/>
               </a:ext>
             </a:extLst>
           </p:cNvPr>
@@ -5088,19 +5088,19 @@
           <p:cNvPr id="8" name="">
             <a:extLst xmlns:a="http://schemas.openxmlformats.org/drawingml/2006/main">
               <a:ext uri="{FF2B5EF4-FFF2-40B4-BE49-F238E27FC236}">
-                <a16:creationId xmlns:a16="http://schemas.microsoft.com/office/drawing/2014/main" id="{8D3C22F3-EBEE-4459-A1A3-EFC4754ADB57}"/>
-              </a:ext>
-            </a:extLst>
-          </p:cNvPr>
-          <p:cNvSpPr>
-            <a:spLocks xmlns:a="http://schemas.openxmlformats.org/drawingml/2006/main" noGrp="1"/>
-          </p:cNvSpPr>
-          <p:nvPr/>
-        </p:nvSpPr>
-        <p:spPr>
-          <a:xfrm xmlns:a="http://schemas.openxmlformats.org/drawingml/2006/main">
-            <a:off x="9448800" y="3657600"/>
-            <a:ext cx="2000250" cy="323850"/>
+                <a16:creationId xmlns:a16="http://schemas.microsoft.com/office/drawing/2014/main" id="{67DE31CD-63BD-49E2-A295-0824A223043B}"/>
+              </a:ext>
+            </a:extLst>
+          </p:cNvPr>
+          <p:cNvSpPr>
+            <a:spLocks xmlns:a="http://schemas.openxmlformats.org/drawingml/2006/main" noGrp="1"/>
+          </p:cNvSpPr>
+          <p:nvPr/>
+        </p:nvSpPr>
+        <p:spPr>
+          <a:xfrm xmlns:a="http://schemas.openxmlformats.org/drawingml/2006/main">
+            <a:off x="9334500" y="3657600"/>
+            <a:ext cx="2190750" cy="323850"/>
           </a:xfrm>
           <a:prstGeom xmlns:a="http://schemas.openxmlformats.org/drawingml/2006/main" prst="rect">
             <a:avLst/>
@@ -5128,7 +5128,7 @@
                   <a:srgbClr val="310019"/>
                 </a:solidFill>
               </a:rPr>
-              <a:t>行动可以复制</a:t>
+              <a:t>给你能直接发的话</a:t>
             </a:r>
           </a:p>
         </p:txBody>
@@ -5138,7 +5138,7 @@
           <p:cNvPr id="9" name="">
             <a:extLst xmlns:a="http://schemas.openxmlformats.org/drawingml/2006/main">
               <a:ext uri="{FF2B5EF4-FFF2-40B4-BE49-F238E27FC236}">
-                <a16:creationId xmlns:a16="http://schemas.microsoft.com/office/drawing/2014/main" id="{0B44E585-EAF4-4E72-A3F8-BA21442B3EF5}"/>
+                <a16:creationId xmlns:a16="http://schemas.microsoft.com/office/drawing/2014/main" id="{D823B1A7-C2FE-4A3B-9BA8-858180B4A4E1}"/>
               </a:ext>
             </a:extLst>
           </p:cNvPr>
@@ -5188,7 +5188,7 @@
           <p:cNvPr id="10" name="">
             <a:extLst xmlns:a="http://schemas.openxmlformats.org/drawingml/2006/main">
               <a:ext uri="{FF2B5EF4-FFF2-40B4-BE49-F238E27FC236}">
-                <a16:creationId xmlns:a16="http://schemas.microsoft.com/office/drawing/2014/main" id="{904C931B-AA75-4F77-B7EA-6BD11A4BAAE1}"/>
+                <a16:creationId xmlns:a16="http://schemas.microsoft.com/office/drawing/2014/main" id="{642AE0FF-9F07-4D1A-9FB0-4D549662F1BB}"/>
               </a:ext>
             </a:extLst>
           </p:cNvPr>
@@ -5228,7 +5228,7 @@
                   <a:srgbClr val="19A86B"/>
                 </a:solidFill>
               </a:rPr>
-              <a:t>最终由用户确认</a:t>
+              <a:t>最后你自己决定</a:t>
             </a:r>
           </a:p>
         </p:txBody>
@@ -5238,7 +5238,7 @@
           <p:cNvPr id="11" name="">
             <a:extLst xmlns:a="http://schemas.openxmlformats.org/drawingml/2006/main">
               <a:ext uri="{FF2B5EF4-FFF2-40B4-BE49-F238E27FC236}">
-                <a16:creationId xmlns:a16="http://schemas.microsoft.com/office/drawing/2014/main" id="{4537ED35-6B1B-4EC9-8E0C-70345B99FC4F}"/>
+                <a16:creationId xmlns:a16="http://schemas.microsoft.com/office/drawing/2014/main" id="{F98F68C2-2E42-400B-911B-495C0A98D341}"/>
               </a:ext>
             </a:extLst>
           </p:cNvPr>
@@ -5288,7 +5288,7 @@
           <p:cNvPr id="12" name="">
             <a:extLst xmlns:a="http://schemas.openxmlformats.org/drawingml/2006/main">
               <a:ext uri="{FF2B5EF4-FFF2-40B4-BE49-F238E27FC236}">
-                <a16:creationId xmlns:a16="http://schemas.microsoft.com/office/drawing/2014/main" id="{511D25A9-B8D0-444E-9A35-FE864AEBC386}"/>
+                <a16:creationId xmlns:a16="http://schemas.microsoft.com/office/drawing/2014/main" id="{6FFE20EC-A4D3-472F-8CD1-B43B1A81CB3C}"/>
               </a:ext>
             </a:extLst>
           </p:cNvPr>
@@ -5336,7 +5336,7 @@
     </p:spTree>
     <p:extLst>
       <p:ext uri="{BB962C8B-B14F-4D97-AF65-F5344CB8AC3E}">
-        <p14:creationId xmlns:p14="http://schemas.microsoft.com/office/powerpoint/2010/main" val="782360984"/>
+        <p14:creationId xmlns:p14="http://schemas.microsoft.com/office/powerpoint/2010/main" val="1547045415"/>
       </p:ext>
     </p:extLst>
   </p:cSld>
@@ -5367,7 +5367,7 @@
           <p:cNvPr id="14" name="">
             <a:extLst xmlns:a="http://schemas.openxmlformats.org/drawingml/2006/main">
               <a:ext uri="{FF2B5EF4-FFF2-40B4-BE49-F238E27FC236}">
-                <a16:creationId xmlns:a16="http://schemas.microsoft.com/office/drawing/2014/main" id="{F20266C7-A94B-44BD-BACA-F5E794226DBA}"/>
+                <a16:creationId xmlns:a16="http://schemas.microsoft.com/office/drawing/2014/main" id="{2866729E-7E13-41E2-85E3-6172BC26F682}"/>
               </a:ext>
             </a:extLst>
           </p:cNvPr>
@@ -5407,7 +5407,7 @@
                   <a:srgbClr val="FF168F"/>
                 </a:solidFill>
               </a:rPr>
-              <a:t>04 · EVIDENCE</a:t>
+              <a:t>04 · 关系进展</a:t>
             </a:r>
           </a:p>
         </p:txBody>
@@ -5417,7 +5417,7 @@
           <p:cNvPr id="2" name="">
             <a:extLst xmlns:a="http://schemas.openxmlformats.org/drawingml/2006/main">
               <a:ext uri="{FF2B5EF4-FFF2-40B4-BE49-F238E27FC236}">
-                <a16:creationId xmlns:a16="http://schemas.microsoft.com/office/drawing/2014/main" id="{51E789B8-60AB-486A-895D-206805E2E03D}"/>
+                <a16:creationId xmlns:a16="http://schemas.microsoft.com/office/drawing/2014/main" id="{5FA73C3C-69C4-41F3-B70E-F7B09C961186}"/>
               </a:ext>
             </a:extLst>
           </p:cNvPr>
@@ -5457,7 +5457,7 @@
                   <a:srgbClr val="FFFFFF"/>
                 </a:solidFill>
               </a:rPr>
-              <a:t>关系进展不是预测，是可回看的证据 K 线</a:t>
+              <a:t>K 线只记录发生过什么，不算“成功率”</a:t>
             </a:r>
           </a:p>
         </p:txBody>
@@ -5467,7 +5467,7 @@
           <p:cNvPr id="3" name="">
             <a:extLst xmlns:a="http://schemas.openxmlformats.org/drawingml/2006/main">
               <a:ext uri="{FF2B5EF4-FFF2-40B4-BE49-F238E27FC236}">
-                <a16:creationId xmlns:a16="http://schemas.microsoft.com/office/drawing/2014/main" id="{D6D57B37-6236-4826-8F28-532727BEE239}"/>
+                <a16:creationId xmlns:a16="http://schemas.microsoft.com/office/drawing/2014/main" id="{F62C19AF-BD1F-417F-BF3B-D7ADF845EE50}"/>
               </a:ext>
             </a:extLst>
           </p:cNvPr>
@@ -5507,7 +5507,7 @@
                   <a:srgbClr val="E9CAD9"/>
                 </a:solidFill>
               </a:rPr>
-              <a:t>红色正向、绿色退缩、灰色证据不足；每根蜡烛都保留事实、来源与完整度。</a:t>
+              <a:t>红色表示有进展，绿色表示退缩或冲突，灰色表示现在还看不清。</a:t>
             </a:r>
           </a:p>
         </p:txBody>
@@ -5517,7 +5517,7 @@
           <p:cNvPr id="4" name="">
             <a:extLst xmlns:a="http://schemas.openxmlformats.org/drawingml/2006/main">
               <a:ext uri="{FF2B5EF4-FFF2-40B4-BE49-F238E27FC236}">
-                <a16:creationId xmlns:a16="http://schemas.microsoft.com/office/drawing/2014/main" id="{87EE1979-FAB8-4408-8F76-55674EDCF1E2}"/>
+                <a16:creationId xmlns:a16="http://schemas.microsoft.com/office/drawing/2014/main" id="{07C70F1C-67EA-4FA4-AC10-209873D8663A}"/>
               </a:ext>
             </a:extLst>
           </p:cNvPr>
@@ -5556,7 +5556,7 @@
           <p:nvPr/>
         </p:nvPicPr>
         <p:blipFill>
-          <a:blip xmlns:r="http://schemas.openxmlformats.org/officeDocument/2006/relationships" xmlns:a="http://schemas.openxmlformats.org/drawingml/2006/main" r:embed="R4087e6b594c2426c"/>
+          <a:blip xmlns:r="http://schemas.openxmlformats.org/officeDocument/2006/relationships" xmlns:a="http://schemas.openxmlformats.org/drawingml/2006/main" r:embed="R56e8be88e798452a"/>
           <a:srcRect xmlns:a="http://schemas.openxmlformats.org/drawingml/2006/main" l="0" t="18056" r="0" b="18056"/>
           <a:stretch xmlns:a="http://schemas.openxmlformats.org/drawingml/2006/main">
             <a:fillRect l="0" t="0" r="0" b="0"/>
@@ -5579,7 +5579,7 @@
           <p:cNvPr id="6" name="">
             <a:extLst xmlns:a="http://schemas.openxmlformats.org/drawingml/2006/main">
               <a:ext uri="{FF2B5EF4-FFF2-40B4-BE49-F238E27FC236}">
-                <a16:creationId xmlns:a16="http://schemas.microsoft.com/office/drawing/2014/main" id="{FE267259-B56B-4D94-9F4E-79CDD2CD8B7F}"/>
+                <a16:creationId xmlns:a16="http://schemas.microsoft.com/office/drawing/2014/main" id="{DEDEF58A-4CCD-4BF9-9E57-8D8AC494707D}"/>
               </a:ext>
             </a:extLst>
           </p:cNvPr>
@@ -5612,7 +5612,7 @@
           <p:cNvPr id="7" name="">
             <a:extLst xmlns:a="http://schemas.openxmlformats.org/drawingml/2006/main">
               <a:ext uri="{FF2B5EF4-FFF2-40B4-BE49-F238E27FC236}">
-                <a16:creationId xmlns:a16="http://schemas.microsoft.com/office/drawing/2014/main" id="{0479252C-17FA-4558-B407-8531B3F8DF0E}"/>
+                <a16:creationId xmlns:a16="http://schemas.microsoft.com/office/drawing/2014/main" id="{1C68EFC8-C856-4EC1-B1E0-0FFE0DFA911F}"/>
               </a:ext>
             </a:extLst>
           </p:cNvPr>
@@ -5652,7 +5652,7 @@
                   <a:srgbClr val="FFFFFF"/>
                 </a:solidFill>
               </a:rPr>
-              <a:t>16 根公开证据</a:t>
+              <a:t>16 条公开记录</a:t>
             </a:r>
           </a:p>
         </p:txBody>
@@ -5662,7 +5662,7 @@
           <p:cNvPr id="8" name="">
             <a:extLst xmlns:a="http://schemas.openxmlformats.org/drawingml/2006/main">
               <a:ext uri="{FF2B5EF4-FFF2-40B4-BE49-F238E27FC236}">
-                <a16:creationId xmlns:a16="http://schemas.microsoft.com/office/drawing/2014/main" id="{C6254057-32CC-4A80-B8F9-F424671408DF}"/>
+                <a16:creationId xmlns:a16="http://schemas.microsoft.com/office/drawing/2014/main" id="{A7A3744F-A879-4AB9-AB40-E87AA3575DB2}"/>
               </a:ext>
             </a:extLst>
           </p:cNvPr>
@@ -5674,7 +5674,7 @@
         <p:spPr>
           <a:xfrm xmlns:a="http://schemas.openxmlformats.org/drawingml/2006/main">
             <a:off x="2419350" y="5695950"/>
-            <a:ext cx="1695450" cy="323850"/>
+            <a:ext cx="1809750" cy="323850"/>
           </a:xfrm>
           <a:prstGeom xmlns:a="http://schemas.openxmlformats.org/drawingml/2006/main" prst="roundRect">
             <a:avLst>
@@ -5695,7 +5695,7 @@
           <p:cNvPr id="9" name="">
             <a:extLst xmlns:a="http://schemas.openxmlformats.org/drawingml/2006/main">
               <a:ext uri="{FF2B5EF4-FFF2-40B4-BE49-F238E27FC236}">
-                <a16:creationId xmlns:a16="http://schemas.microsoft.com/office/drawing/2014/main" id="{1B5A47B5-8E6A-43F9-8A9C-D3E36894C1FE}"/>
+                <a16:creationId xmlns:a16="http://schemas.microsoft.com/office/drawing/2014/main" id="{F6CE482F-3A0D-400F-BE5F-D587BD9E3652}"/>
               </a:ext>
             </a:extLst>
           </p:cNvPr>
@@ -5707,7 +5707,7 @@
         <p:spPr>
           <a:xfrm xmlns:a="http://schemas.openxmlformats.org/drawingml/2006/main">
             <a:off x="2533650" y="5743575"/>
-            <a:ext cx="1466850" cy="228600"/>
+            <a:ext cx="1581150" cy="228600"/>
           </a:xfrm>
           <a:prstGeom xmlns:a="http://schemas.openxmlformats.org/drawingml/2006/main" prst="rect">
             <a:avLst/>
@@ -5735,7 +5735,7 @@
                   <a:srgbClr val="FFFFFF"/>
                 </a:solidFill>
               </a:rPr>
-              <a:t>OHLC + 成交量</a:t>
+              <a:t>像股票 K 线一样看</a:t>
             </a:r>
           </a:p>
         </p:txBody>
@@ -5745,19 +5745,19 @@
           <p:cNvPr id="10" name="">
             <a:extLst xmlns:a="http://schemas.openxmlformats.org/drawingml/2006/main">
               <a:ext uri="{FF2B5EF4-FFF2-40B4-BE49-F238E27FC236}">
-                <a16:creationId xmlns:a16="http://schemas.microsoft.com/office/drawing/2014/main" id="{0E91C08E-4927-4ECB-9C57-7812966AE117}"/>
-              </a:ext>
-            </a:extLst>
-          </p:cNvPr>
-          <p:cNvSpPr>
-            <a:spLocks xmlns:a="http://schemas.openxmlformats.org/drawingml/2006/main" noGrp="1"/>
-          </p:cNvSpPr>
-          <p:nvPr/>
-        </p:nvSpPr>
-        <p:spPr>
-          <a:xfrm xmlns:a="http://schemas.openxmlformats.org/drawingml/2006/main">
-            <a:off x="4229100" y="5695950"/>
-            <a:ext cx="1524000" cy="323850"/>
+                <a16:creationId xmlns:a16="http://schemas.microsoft.com/office/drawing/2014/main" id="{D50FB47D-6BBC-423A-8324-2CDE46CD5431}"/>
+              </a:ext>
+            </a:extLst>
+          </p:cNvPr>
+          <p:cNvSpPr>
+            <a:spLocks xmlns:a="http://schemas.openxmlformats.org/drawingml/2006/main" noGrp="1"/>
+          </p:cNvSpPr>
+          <p:nvPr/>
+        </p:nvSpPr>
+        <p:spPr>
+          <a:xfrm xmlns:a="http://schemas.openxmlformats.org/drawingml/2006/main">
+            <a:off x="4343400" y="5695950"/>
+            <a:ext cx="1790700" cy="323850"/>
           </a:xfrm>
           <a:prstGeom xmlns:a="http://schemas.openxmlformats.org/drawingml/2006/main" prst="roundRect">
             <a:avLst>
@@ -5778,19 +5778,19 @@
           <p:cNvPr id="11" name="">
             <a:extLst xmlns:a="http://schemas.openxmlformats.org/drawingml/2006/main">
               <a:ext uri="{FF2B5EF4-FFF2-40B4-BE49-F238E27FC236}">
-                <a16:creationId xmlns:a16="http://schemas.microsoft.com/office/drawing/2014/main" id="{B93A2B1A-0D8E-47F2-BE61-690DCD5F53BA}"/>
-              </a:ext>
-            </a:extLst>
-          </p:cNvPr>
-          <p:cNvSpPr>
-            <a:spLocks xmlns:a="http://schemas.openxmlformats.org/drawingml/2006/main" noGrp="1"/>
-          </p:cNvSpPr>
-          <p:nvPr/>
-        </p:nvSpPr>
-        <p:spPr>
-          <a:xfrm xmlns:a="http://schemas.openxmlformats.org/drawingml/2006/main">
-            <a:off x="4343400" y="5743575"/>
-            <a:ext cx="1295400" cy="228600"/>
+                <a16:creationId xmlns:a16="http://schemas.microsoft.com/office/drawing/2014/main" id="{1F02F93C-7A1E-4ABF-AECD-26BBFE6136D4}"/>
+              </a:ext>
+            </a:extLst>
+          </p:cNvPr>
+          <p:cNvSpPr>
+            <a:spLocks xmlns:a="http://schemas.openxmlformats.org/drawingml/2006/main" noGrp="1"/>
+          </p:cNvSpPr>
+          <p:nvPr/>
+        </p:nvSpPr>
+        <p:spPr>
+          <a:xfrm xmlns:a="http://schemas.openxmlformats.org/drawingml/2006/main">
+            <a:off x="4457700" y="5743575"/>
+            <a:ext cx="1562100" cy="228600"/>
           </a:xfrm>
           <a:prstGeom xmlns:a="http://schemas.openxmlformats.org/drawingml/2006/main" prst="rect">
             <a:avLst/>
@@ -5818,7 +5818,7 @@
                   <a:srgbClr val="FFFFFF"/>
                 </a:solidFill>
               </a:rPr>
-              <a:t>悬停查看来源</a:t>
+              <a:t>鼠标放上去看原因</a:t>
             </a:r>
           </a:p>
         </p:txBody>
@@ -5828,7 +5828,7 @@
           <p:cNvPr id="12" name="">
             <a:extLst xmlns:a="http://schemas.openxmlformats.org/drawingml/2006/main">
               <a:ext uri="{FF2B5EF4-FFF2-40B4-BE49-F238E27FC236}">
-                <a16:creationId xmlns:a16="http://schemas.microsoft.com/office/drawing/2014/main" id="{93F09DBC-9047-48D3-B643-495ED20BE187}"/>
+                <a16:creationId xmlns:a16="http://schemas.microsoft.com/office/drawing/2014/main" id="{8E3B4798-A9D1-42FF-A446-0793C90020BC}"/>
               </a:ext>
             </a:extLst>
           </p:cNvPr>
@@ -5878,7 +5878,7 @@
           <p:cNvPr id="13" name="">
             <a:extLst xmlns:a="http://schemas.openxmlformats.org/drawingml/2006/main">
               <a:ext uri="{FF2B5EF4-FFF2-40B4-BE49-F238E27FC236}">
-                <a16:creationId xmlns:a16="http://schemas.microsoft.com/office/drawing/2014/main" id="{8F00EE47-5DCC-4E13-86B7-A564916B7C63}"/>
+                <a16:creationId xmlns:a16="http://schemas.microsoft.com/office/drawing/2014/main" id="{30E5F168-BC0F-4970-B4AE-D9DBCCF9B1CD}"/>
               </a:ext>
             </a:extLst>
           </p:cNvPr>
@@ -5926,7 +5926,7 @@
     </p:spTree>
     <p:extLst>
       <p:ext uri="{BB962C8B-B14F-4D97-AF65-F5344CB8AC3E}">
-        <p14:creationId xmlns:p14="http://schemas.microsoft.com/office/powerpoint/2010/main" val="79041630"/>
+        <p14:creationId xmlns:p14="http://schemas.microsoft.com/office/powerpoint/2010/main" val="1942957991"/>
       </p:ext>
     </p:extLst>
   </p:cSld>
@@ -5957,7 +5957,7 @@
           <p:cNvPr id="18" name="">
             <a:extLst xmlns:a="http://schemas.openxmlformats.org/drawingml/2006/main">
               <a:ext uri="{FF2B5EF4-FFF2-40B4-BE49-F238E27FC236}">
-                <a16:creationId xmlns:a16="http://schemas.microsoft.com/office/drawing/2014/main" id="{113D9298-1309-44CE-9196-72DF7E9F7126}"/>
+                <a16:creationId xmlns:a16="http://schemas.microsoft.com/office/drawing/2014/main" id="{DBFE63C8-92A4-4DF6-816D-6EBD93EC21CC}"/>
               </a:ext>
             </a:extLst>
           </p:cNvPr>
@@ -5997,7 +5997,7 @@
                   <a:srgbClr val="FF168F"/>
                 </a:solidFill>
               </a:rPr>
-              <a:t>05 · ARCHITECTURE</a:t>
+              <a:t>05 · 它不是套壳</a:t>
             </a:r>
           </a:p>
         </p:txBody>
@@ -6007,7 +6007,7 @@
           <p:cNvPr id="2" name="">
             <a:extLst xmlns:a="http://schemas.openxmlformats.org/drawingml/2006/main">
               <a:ext uri="{FF2B5EF4-FFF2-40B4-BE49-F238E27FC236}">
-                <a16:creationId xmlns:a16="http://schemas.microsoft.com/office/drawing/2014/main" id="{5FDA2ADE-E46B-4B72-86F5-B84C3C2D8048}"/>
+                <a16:creationId xmlns:a16="http://schemas.microsoft.com/office/drawing/2014/main" id="{C7A969CD-642A-4E60-9340-EF691BA7ECEC}"/>
               </a:ext>
             </a:extLst>
           </p:cNvPr>
@@ -6047,7 +6047,7 @@
                   <a:srgbClr val="25121D"/>
                 </a:solidFill>
               </a:rPr>
-              <a:t>不是仿 Harness UI，而是运行在 Harness 里的垂直 Agent</a:t>
+              <a:t>不是做了个像 DeepSeek 的页面，而是真的接进去</a:t>
             </a:r>
           </a:p>
         </p:txBody>
@@ -6057,7 +6057,7 @@
           <p:cNvPr id="3" name="">
             <a:extLst xmlns:a="http://schemas.openxmlformats.org/drawingml/2006/main">
               <a:ext uri="{FF2B5EF4-FFF2-40B4-BE49-F238E27FC236}">
-                <a16:creationId xmlns:a16="http://schemas.microsoft.com/office/drawing/2014/main" id="{FA97D54B-EA4D-4848-9471-9AC7082CB593}"/>
+                <a16:creationId xmlns:a16="http://schemas.microsoft.com/office/drawing/2014/main" id="{BD26A2CA-EB6D-422A-B19D-7E2EFD48AB7D}"/>
               </a:ext>
             </a:extLst>
           </p:cNvPr>
@@ -6097,7 +6097,7 @@
                   <a:srgbClr val="765C6A"/>
                 </a:solidFill>
               </a:rPr>
-              <a:t>官方底座负责 Agent、会话、模型、工具与插件；狗头军师 Skill 保持只读。</a:t>
+              <a:t>DeepSeek Harness 负责对话、模型、工具和页面；狗头军师负责感情问题。</a:t>
             </a:r>
           </a:p>
         </p:txBody>
@@ -6107,7 +6107,7 @@
           <p:cNvPr id="4" name="">
             <a:extLst xmlns:a="http://schemas.openxmlformats.org/drawingml/2006/main">
               <a:ext uri="{FF2B5EF4-FFF2-40B4-BE49-F238E27FC236}">
-                <a16:creationId xmlns:a16="http://schemas.microsoft.com/office/drawing/2014/main" id="{555A094E-EFB5-4F3A-9BF2-A5EDAAA43D8D}"/>
+                <a16:creationId xmlns:a16="http://schemas.microsoft.com/office/drawing/2014/main" id="{DA0B23AC-0B1F-4ACB-A0D4-5D10828804F1}"/>
               </a:ext>
             </a:extLst>
           </p:cNvPr>
@@ -6142,7 +6142,7 @@
           <p:cNvPr id="5" name="">
             <a:extLst xmlns:a="http://schemas.openxmlformats.org/drawingml/2006/main">
               <a:ext uri="{FF2B5EF4-FFF2-40B4-BE49-F238E27FC236}">
-                <a16:creationId xmlns:a16="http://schemas.microsoft.com/office/drawing/2014/main" id="{29139CDD-A4A1-43CD-92E0-5BA515CA8658}"/>
+                <a16:creationId xmlns:a16="http://schemas.microsoft.com/office/drawing/2014/main" id="{89C442A6-89C9-4C5A-AD3F-C55C682BA71D}"/>
               </a:ext>
             </a:extLst>
           </p:cNvPr>
@@ -6182,7 +6182,7 @@
                   <a:srgbClr val="FFFFFF"/>
                 </a:solidFill>
               </a:rPr>
-              <a:t>DeepSeek Harness 0.1.0-rc.6</a:t>
+              <a:t>DeepSeek Harness</a:t>
             </a:r>
           </a:p>
         </p:txBody>
@@ -6192,7 +6192,7 @@
           <p:cNvPr id="6" name="">
             <a:extLst xmlns:a="http://schemas.openxmlformats.org/drawingml/2006/main">
               <a:ext uri="{FF2B5EF4-FFF2-40B4-BE49-F238E27FC236}">
-                <a16:creationId xmlns:a16="http://schemas.microsoft.com/office/drawing/2014/main" id="{6D60766F-5466-4506-BA6B-075D45CA6FD0}"/>
+                <a16:creationId xmlns:a16="http://schemas.microsoft.com/office/drawing/2014/main" id="{4A197E3B-E0AD-4B37-86E2-AE2D9D6AC583}"/>
               </a:ext>
             </a:extLst>
           </p:cNvPr>
@@ -6232,7 +6232,7 @@
                   <a:srgbClr val="F4DCE8"/>
                 </a:solidFill>
               </a:rPr>
-              <a:t>Agent · 会话 · 模型提供方 · Web runtime · plugin host</a:t>
+              <a:t>负责对话、模型、工具和整个工作区</a:t>
             </a:r>
           </a:p>
         </p:txBody>
@@ -6242,7 +6242,7 @@
           <p:cNvPr id="7" name="">
             <a:extLst xmlns:a="http://schemas.openxmlformats.org/drawingml/2006/main">
               <a:ext uri="{FF2B5EF4-FFF2-40B4-BE49-F238E27FC236}">
-                <a16:creationId xmlns:a16="http://schemas.microsoft.com/office/drawing/2014/main" id="{AC503BED-CBE1-446B-9B91-24B0815972C8}"/>
+                <a16:creationId xmlns:a16="http://schemas.microsoft.com/office/drawing/2014/main" id="{395A4BFD-8158-4BC9-B6B7-D2B13CC25440}"/>
               </a:ext>
             </a:extLst>
           </p:cNvPr>
@@ -6277,7 +6277,7 @@
           <p:cNvPr id="8" name="">
             <a:extLst xmlns:a="http://schemas.openxmlformats.org/drawingml/2006/main">
               <a:ext uri="{FF2B5EF4-FFF2-40B4-BE49-F238E27FC236}">
-                <a16:creationId xmlns:a16="http://schemas.microsoft.com/office/drawing/2014/main" id="{ACC61E77-0388-4B92-90CB-B569F2EA010A}"/>
+                <a16:creationId xmlns:a16="http://schemas.microsoft.com/office/drawing/2014/main" id="{46643972-3BCC-44B4-B740-A2A55D5842EE}"/>
               </a:ext>
             </a:extLst>
           </p:cNvPr>
@@ -6317,7 +6317,7 @@
                   <a:srgbClr val="FFFFFF"/>
                 </a:solidFill>
               </a:rPr>
-              <a:t>参赛适配层</a:t>
+              <a:t>这次比赛新增的部分</a:t>
             </a:r>
           </a:p>
         </p:txBody>
@@ -6327,7 +6327,7 @@
           <p:cNvPr id="9" name="">
             <a:extLst xmlns:a="http://schemas.openxmlformats.org/drawingml/2006/main">
               <a:ext uri="{FF2B5EF4-FFF2-40B4-BE49-F238E27FC236}">
-                <a16:creationId xmlns:a16="http://schemas.microsoft.com/office/drawing/2014/main" id="{79C7352A-6358-4EB0-9D0B-D306D2327869}"/>
+                <a16:creationId xmlns:a16="http://schemas.microsoft.com/office/drawing/2014/main" id="{C9C73E36-AA15-4601-88EC-EA27D23322E2}"/>
               </a:ext>
             </a:extLst>
           </p:cNvPr>
@@ -6367,7 +6367,7 @@
                   <a:srgbClr val="F4DCE8"/>
                 </a:solidFill>
               </a:rPr>
-              <a:t>bundle · client slots · reference / evidence / memory tools</a:t>
+              <a:t>把关系判断、证据图和记忆功能接进来</a:t>
             </a:r>
           </a:p>
         </p:txBody>
@@ -6377,7 +6377,7 @@
           <p:cNvPr id="10" name="">
             <a:extLst xmlns:a="http://schemas.openxmlformats.org/drawingml/2006/main">
               <a:ext uri="{FF2B5EF4-FFF2-40B4-BE49-F238E27FC236}">
-                <a16:creationId xmlns:a16="http://schemas.microsoft.com/office/drawing/2014/main" id="{EEACBB40-2500-46E2-A3C2-32A971FF7FB3}"/>
+                <a16:creationId xmlns:a16="http://schemas.microsoft.com/office/drawing/2014/main" id="{A301F4C0-3E94-4E81-B588-3849C85FA892}"/>
               </a:ext>
             </a:extLst>
           </p:cNvPr>
@@ -6412,7 +6412,7 @@
           <p:cNvPr id="11" name="">
             <a:extLst xmlns:a="http://schemas.openxmlformats.org/drawingml/2006/main">
               <a:ext uri="{FF2B5EF4-FFF2-40B4-BE49-F238E27FC236}">
-                <a16:creationId xmlns:a16="http://schemas.microsoft.com/office/drawing/2014/main" id="{47F82972-AD1C-421D-AB7D-2325E17A1AB0}"/>
+                <a16:creationId xmlns:a16="http://schemas.microsoft.com/office/drawing/2014/main" id="{A720353F-61F1-4958-A09F-6D3AD9B19259}"/>
               </a:ext>
             </a:extLst>
           </p:cNvPr>
@@ -6452,7 +6452,7 @@
                   <a:srgbClr val="25121D"/>
                 </a:solidFill>
               </a:rPr>
-              <a:t>只读狗头军师 Skill</a:t>
+              <a:t>原来的狗头军师 Skill</a:t>
             </a:r>
           </a:p>
         </p:txBody>
@@ -6462,7 +6462,7 @@
           <p:cNvPr id="12" name="">
             <a:extLst xmlns:a="http://schemas.openxmlformats.org/drawingml/2006/main">
               <a:ext uri="{FF2B5EF4-FFF2-40B4-BE49-F238E27FC236}">
-                <a16:creationId xmlns:a16="http://schemas.microsoft.com/office/drawing/2014/main" id="{A7D1DCB2-A901-480D-B939-FDCBFB0B5436}"/>
+                <a16:creationId xmlns:a16="http://schemas.microsoft.com/office/drawing/2014/main" id="{78FD37DF-865A-498C-9B99-C685E874F49F}"/>
               </a:ext>
             </a:extLst>
           </p:cNvPr>
@@ -6502,7 +6502,7 @@
                   <a:srgbClr val="765C6A"/>
                 </a:solidFill>
               </a:rPr>
-              <a:t>按需路由 1–3 份参考 · 既有素材与记忆脚本不被修改</a:t>
+              <a:t>原文件不动；遇到问题时，只查 1–3 份需要的资料</a:t>
             </a:r>
           </a:p>
         </p:txBody>
@@ -6512,7 +6512,7 @@
           <p:cNvPr id="13" name="">
             <a:extLst xmlns:a="http://schemas.openxmlformats.org/drawingml/2006/main">
               <a:ext uri="{FF2B5EF4-FFF2-40B4-BE49-F238E27FC236}">
-                <a16:creationId xmlns:a16="http://schemas.microsoft.com/office/drawing/2014/main" id="{C51F105F-318D-41D7-8395-ED5F95D87488}"/>
+                <a16:creationId xmlns:a16="http://schemas.microsoft.com/office/drawing/2014/main" id="{BB9950A0-AE0B-40B0-ADB7-73C326E5B7ED}"/>
               </a:ext>
             </a:extLst>
           </p:cNvPr>
@@ -6551,7 +6551,7 @@
           <p:nvPr/>
         </p:nvPicPr>
         <p:blipFill>
-          <a:blip xmlns:r="http://schemas.openxmlformats.org/officeDocument/2006/relationships" xmlns:a="http://schemas.openxmlformats.org/drawingml/2006/main" r:embed="R720bd1ba7bb74aee"/>
+          <a:blip xmlns:r="http://schemas.openxmlformats.org/officeDocument/2006/relationships" xmlns:a="http://schemas.openxmlformats.org/drawingml/2006/main" r:embed="Rf6b3e397797e444a"/>
           <a:srcRect xmlns:a="http://schemas.openxmlformats.org/drawingml/2006/main" l="21023" t="0" r="21023" b="0"/>
           <a:stretch xmlns:a="http://schemas.openxmlformats.org/drawingml/2006/main">
             <a:fillRect l="0" t="0" r="0" b="0"/>
@@ -6574,19 +6574,19 @@
           <p:cNvPr id="15" name="">
             <a:extLst xmlns:a="http://schemas.openxmlformats.org/drawingml/2006/main">
               <a:ext uri="{FF2B5EF4-FFF2-40B4-BE49-F238E27FC236}">
-                <a16:creationId xmlns:a16="http://schemas.microsoft.com/office/drawing/2014/main" id="{943132FF-4568-4451-B382-FDDD3253C503}"/>
-              </a:ext>
-            </a:extLst>
-          </p:cNvPr>
-          <p:cNvSpPr>
-            <a:spLocks xmlns:a="http://schemas.openxmlformats.org/drawingml/2006/main" noGrp="1"/>
-          </p:cNvSpPr>
-          <p:nvPr/>
-        </p:nvSpPr>
-        <p:spPr>
-          <a:xfrm xmlns:a="http://schemas.openxmlformats.org/drawingml/2006/main">
-            <a:off x="8058150" y="5743575"/>
-            <a:ext cx="3238500" cy="285750"/>
+                <a16:creationId xmlns:a16="http://schemas.microsoft.com/office/drawing/2014/main" id="{CFCA6F1D-18C7-477B-9173-531B9FC806DD}"/>
+              </a:ext>
+            </a:extLst>
+          </p:cNvPr>
+          <p:cNvSpPr>
+            <a:spLocks xmlns:a="http://schemas.openxmlformats.org/drawingml/2006/main" noGrp="1"/>
+          </p:cNvSpPr>
+          <p:nvPr/>
+        </p:nvSpPr>
+        <p:spPr>
+          <a:xfrm xmlns:a="http://schemas.openxmlformats.org/drawingml/2006/main">
+            <a:off x="7905750" y="5743575"/>
+            <a:ext cx="3543300" cy="285750"/>
           </a:xfrm>
           <a:prstGeom xmlns:a="http://schemas.openxmlformats.org/drawingml/2006/main" prst="rect">
             <a:avLst/>
@@ -6614,7 +6614,7 @@
                   <a:srgbClr val="310019"/>
                 </a:solidFill>
               </a:rPr>
-              <a:t>API Key 由官方模型设置管理</a:t>
+              <a:t>API Key 仍放在 DeepSeek 自己的设置里</a:t>
             </a:r>
           </a:p>
         </p:txBody>
@@ -6624,7 +6624,7 @@
           <p:cNvPr id="16" name="">
             <a:extLst xmlns:a="http://schemas.openxmlformats.org/drawingml/2006/main">
               <a:ext uri="{FF2B5EF4-FFF2-40B4-BE49-F238E27FC236}">
-                <a16:creationId xmlns:a16="http://schemas.microsoft.com/office/drawing/2014/main" id="{3A40F334-402D-4B16-8BC3-452293ECAEB8}"/>
+                <a16:creationId xmlns:a16="http://schemas.microsoft.com/office/drawing/2014/main" id="{A708BEEB-541F-4E21-9E08-3C389839E908}"/>
               </a:ext>
             </a:extLst>
           </p:cNvPr>
@@ -6674,7 +6674,7 @@
           <p:cNvPr id="17" name="">
             <a:extLst xmlns:a="http://schemas.openxmlformats.org/drawingml/2006/main">
               <a:ext uri="{FF2B5EF4-FFF2-40B4-BE49-F238E27FC236}">
-                <a16:creationId xmlns:a16="http://schemas.microsoft.com/office/drawing/2014/main" id="{37E4D464-86A4-474F-A2FF-B9E4BB9517EF}"/>
+                <a16:creationId xmlns:a16="http://schemas.microsoft.com/office/drawing/2014/main" id="{B929BAC4-6B11-4282-9464-5A64ED4F0F43}"/>
               </a:ext>
             </a:extLst>
           </p:cNvPr>
@@ -6722,7 +6722,7 @@
     </p:spTree>
     <p:extLst>
       <p:ext uri="{BB962C8B-B14F-4D97-AF65-F5344CB8AC3E}">
-        <p14:creationId xmlns:p14="http://schemas.microsoft.com/office/powerpoint/2010/main" val="1724735384"/>
+        <p14:creationId xmlns:p14="http://schemas.microsoft.com/office/powerpoint/2010/main" val="2107513507"/>
       </p:ext>
     </p:extLst>
   </p:cSld>
@@ -6753,7 +6753,7 @@
           <p:cNvPr id="20" name="">
             <a:extLst xmlns:a="http://schemas.openxmlformats.org/drawingml/2006/main">
               <a:ext uri="{FF2B5EF4-FFF2-40B4-BE49-F238E27FC236}">
-                <a16:creationId xmlns:a16="http://schemas.microsoft.com/office/drawing/2014/main" id="{1232647F-64B5-458C-ABC0-778EB7803D32}"/>
+                <a16:creationId xmlns:a16="http://schemas.microsoft.com/office/drawing/2014/main" id="{154FA0DF-DFA8-4BAC-9F63-40E15F50BB0C}"/>
               </a:ext>
             </a:extLst>
           </p:cNvPr>
@@ -6793,7 +6793,7 @@
                   <a:srgbClr val="FF168F"/>
                 </a:solidFill>
               </a:rPr>
-              <a:t>06 · SAFETY</a:t>
+              <a:t>06 · 隐私和安全</a:t>
             </a:r>
           </a:p>
         </p:txBody>
@@ -6803,7 +6803,7 @@
           <p:cNvPr id="2" name="">
             <a:extLst xmlns:a="http://schemas.openxmlformats.org/drawingml/2006/main">
               <a:ext uri="{FF2B5EF4-FFF2-40B4-BE49-F238E27FC236}">
-                <a16:creationId xmlns:a16="http://schemas.microsoft.com/office/drawing/2014/main" id="{BD633988-0F58-4F91-B1B3-0E546611819D}"/>
+                <a16:creationId xmlns:a16="http://schemas.microsoft.com/office/drawing/2014/main" id="{6285581B-3A69-4DAE-80FF-651DD8BE1EE2}"/>
               </a:ext>
             </a:extLst>
           </p:cNvPr>
@@ -6843,7 +6843,7 @@
                   <a:srgbClr val="25121D"/>
                 </a:solidFill>
               </a:rPr>
-              <a:t>高情绪场景必须先把边界做成产品能力</a:t>
+              <a:t>这类问题很私密，所以先把边界说清楚</a:t>
             </a:r>
           </a:p>
         </p:txBody>
@@ -6853,7 +6853,7 @@
           <p:cNvPr id="3" name="">
             <a:extLst xmlns:a="http://schemas.openxmlformats.org/drawingml/2006/main">
               <a:ext uri="{FF2B5EF4-FFF2-40B4-BE49-F238E27FC236}">
-                <a16:creationId xmlns:a16="http://schemas.microsoft.com/office/drawing/2014/main" id="{785399EA-7470-4556-883B-CFC4125BC285}"/>
+                <a16:creationId xmlns:a16="http://schemas.microsoft.com/office/drawing/2014/main" id="{B8CD666C-8389-4E5A-B541-FE190FE70FD3}"/>
               </a:ext>
             </a:extLst>
           </p:cNvPr>
@@ -6893,7 +6893,7 @@
                   <a:srgbClr val="765C6A"/>
                 </a:solidFill>
               </a:rPr>
-              <a:t>隐私、身份和行动权不是提示词承诺，而是可检查的限制。</a:t>
+              <a:t>不认错人、不串资料、不偷看，也不替用户发消息。</a:t>
             </a:r>
           </a:p>
         </p:txBody>
@@ -6903,7 +6903,7 @@
           <p:cNvPr id="4" name="">
             <a:extLst xmlns:a="http://schemas.openxmlformats.org/drawingml/2006/main">
               <a:ext uri="{FF2B5EF4-FFF2-40B4-BE49-F238E27FC236}">
-                <a16:creationId xmlns:a16="http://schemas.microsoft.com/office/drawing/2014/main" id="{08205348-C79B-4D6E-ABB5-85FA7BE54389}"/>
+                <a16:creationId xmlns:a16="http://schemas.microsoft.com/office/drawing/2014/main" id="{BEA77ECB-B68A-45E2-A086-17F255DA37DA}"/>
               </a:ext>
             </a:extLst>
           </p:cNvPr>
@@ -6942,7 +6942,7 @@
           <p:nvPr/>
         </p:nvPicPr>
         <p:blipFill>
-          <a:blip xmlns:r="http://schemas.openxmlformats.org/officeDocument/2006/relationships" xmlns:a="http://schemas.openxmlformats.org/drawingml/2006/main" r:embed="Rff5d7980a7fb400d"/>
+          <a:blip xmlns:r="http://schemas.openxmlformats.org/officeDocument/2006/relationships" xmlns:a="http://schemas.openxmlformats.org/drawingml/2006/main" r:embed="Ra28b8dfee045494c"/>
           <a:stretch xmlns:a="http://schemas.openxmlformats.org/drawingml/2006/main"/>
         </p:blipFill>
         <p:spPr>
@@ -6962,7 +6962,7 @@
           <p:cNvPr id="6" name="">
             <a:extLst xmlns:a="http://schemas.openxmlformats.org/drawingml/2006/main">
               <a:ext uri="{FF2B5EF4-FFF2-40B4-BE49-F238E27FC236}">
-                <a16:creationId xmlns:a16="http://schemas.microsoft.com/office/drawing/2014/main" id="{A65F716F-5EB7-4E6A-A3B5-3B639C74F8DE}"/>
+                <a16:creationId xmlns:a16="http://schemas.microsoft.com/office/drawing/2014/main" id="{B024FBAA-4A8C-42C5-961E-F3DDEC7A41CA}"/>
               </a:ext>
             </a:extLst>
           </p:cNvPr>
@@ -7002,7 +7002,7 @@
                   <a:srgbClr val="FF168F"/>
                 </a:solidFill>
               </a:rPr>
-              <a:t>防认反</a:t>
+              <a:t>先确认身份</a:t>
             </a:r>
           </a:p>
         </p:txBody>
@@ -7012,7 +7012,7 @@
           <p:cNvPr id="7" name="">
             <a:extLst xmlns:a="http://schemas.openxmlformats.org/drawingml/2006/main">
               <a:ext uri="{FF2B5EF4-FFF2-40B4-BE49-F238E27FC236}">
-                <a16:creationId xmlns:a16="http://schemas.microsoft.com/office/drawing/2014/main" id="{F0D5F91C-3462-4BC5-9E17-E1E60DB45FC2}"/>
+                <a16:creationId xmlns:a16="http://schemas.microsoft.com/office/drawing/2014/main" id="{5EB7031A-E169-4B90-8685-DF4A9C1BCB56}"/>
               </a:ext>
             </a:extLst>
           </p:cNvPr>
@@ -7052,7 +7052,7 @@
                   <a:srgbClr val="25121D"/>
                 </a:solidFill>
               </a:rPr>
-              <a:t>优先 sender/member ID；元数据不足时由用户确认锚点，冲突立即停止。</a:t>
+              <a:t>优先看发送人账号；信息不够就请用户确认，前后对不上马上停。</a:t>
             </a:r>
           </a:p>
         </p:txBody>
@@ -7062,7 +7062,7 @@
           <p:cNvPr id="8" name="">
             <a:extLst xmlns:a="http://schemas.openxmlformats.org/drawingml/2006/main">
               <a:ext uri="{FF2B5EF4-FFF2-40B4-BE49-F238E27FC236}">
-                <a16:creationId xmlns:a16="http://schemas.microsoft.com/office/drawing/2014/main" id="{A9EE5A55-EDF3-414F-BEB1-9D6ECDDA79F9}"/>
+                <a16:creationId xmlns:a16="http://schemas.microsoft.com/office/drawing/2014/main" id="{D21AF140-905A-45FB-8031-3DCC6350B9ED}"/>
               </a:ext>
             </a:extLst>
           </p:cNvPr>
@@ -7095,7 +7095,7 @@
           <p:cNvPr id="9" name="">
             <a:extLst xmlns:a="http://schemas.openxmlformats.org/drawingml/2006/main">
               <a:ext uri="{FF2B5EF4-FFF2-40B4-BE49-F238E27FC236}">
-                <a16:creationId xmlns:a16="http://schemas.microsoft.com/office/drawing/2014/main" id="{63E7A619-D9A6-40F8-A22A-3FA66A2217FA}"/>
+                <a16:creationId xmlns:a16="http://schemas.microsoft.com/office/drawing/2014/main" id="{3832B065-4F7F-422C-B427-5DEB26D767BE}"/>
               </a:ext>
             </a:extLst>
           </p:cNvPr>
@@ -7135,7 +7135,7 @@
                   <a:srgbClr val="310019"/>
                 </a:solidFill>
               </a:rPr>
-              <a:t>不串档</a:t>
+              <a:t>资料不混</a:t>
             </a:r>
           </a:p>
         </p:txBody>
@@ -7145,7 +7145,7 @@
           <p:cNvPr id="10" name="">
             <a:extLst xmlns:a="http://schemas.openxmlformats.org/drawingml/2006/main">
               <a:ext uri="{FF2B5EF4-FFF2-40B4-BE49-F238E27FC236}">
-                <a16:creationId xmlns:a16="http://schemas.microsoft.com/office/drawing/2014/main" id="{B6DB6501-BE1E-483B-9D6E-D08E71051730}"/>
+                <a16:creationId xmlns:a16="http://schemas.microsoft.com/office/drawing/2014/main" id="{00B28A8B-4B56-4DCE-A711-65773C0AE319}"/>
               </a:ext>
             </a:extLst>
           </p:cNvPr>
@@ -7185,7 +7185,7 @@
                   <a:srgbClr val="25121D"/>
                 </a:solidFill>
               </a:rPr>
-              <a:t>对象 ID 分区会话、记忆、证据和任务，最多 5 个稳定对象。</a:t>
+              <a:t>最多建 5 个档案，每个人的聊天、记忆和证据都单独放。</a:t>
             </a:r>
           </a:p>
         </p:txBody>
@@ -7195,7 +7195,7 @@
           <p:cNvPr id="11" name="">
             <a:extLst xmlns:a="http://schemas.openxmlformats.org/drawingml/2006/main">
               <a:ext uri="{FF2B5EF4-FFF2-40B4-BE49-F238E27FC236}">
-                <a16:creationId xmlns:a16="http://schemas.microsoft.com/office/drawing/2014/main" id="{BA917B05-54F7-49D3-A032-DE36BC4F4250}"/>
+                <a16:creationId xmlns:a16="http://schemas.microsoft.com/office/drawing/2014/main" id="{7C6345F1-BD8D-4B70-B53A-1541DCA27BFF}"/>
               </a:ext>
             </a:extLst>
           </p:cNvPr>
@@ -7228,7 +7228,7 @@
           <p:cNvPr id="12" name="">
             <a:extLst xmlns:a="http://schemas.openxmlformats.org/drawingml/2006/main">
               <a:ext uri="{FF2B5EF4-FFF2-40B4-BE49-F238E27FC236}">
-                <a16:creationId xmlns:a16="http://schemas.microsoft.com/office/drawing/2014/main" id="{6069E075-4CB3-4EA9-851D-9C4050B665F1}"/>
+                <a16:creationId xmlns:a16="http://schemas.microsoft.com/office/drawing/2014/main" id="{63362EBB-1738-44EF-8F07-013F3D642053}"/>
               </a:ext>
             </a:extLst>
           </p:cNvPr>
@@ -7268,7 +7268,7 @@
                   <a:srgbClr val="310019"/>
                 </a:solidFill>
               </a:rPr>
-              <a:t>不越权</a:t>
+              <a:t>不偷看</a:t>
             </a:r>
           </a:p>
         </p:txBody>
@@ -7278,7 +7278,7 @@
           <p:cNvPr id="13" name="">
             <a:extLst xmlns:a="http://schemas.openxmlformats.org/drawingml/2006/main">
               <a:ext uri="{FF2B5EF4-FFF2-40B4-BE49-F238E27FC236}">
-                <a16:creationId xmlns:a16="http://schemas.microsoft.com/office/drawing/2014/main" id="{590BC8DD-63A9-430A-BA7E-6C930E73D83F}"/>
+                <a16:creationId xmlns:a16="http://schemas.microsoft.com/office/drawing/2014/main" id="{54C89612-0B4E-4EDD-AC5A-527FE3CC69F4}"/>
               </a:ext>
             </a:extLst>
           </p:cNvPr>
@@ -7318,7 +7318,7 @@
                   <a:srgbClr val="25121D"/>
                 </a:solidFill>
               </a:rPr>
-              <a:t>不解密数据库、不后台监控、不绕过权限、不自动发送消息。</a:t>
+              <a:t>不破解聊天数据库、不后台监控、不绕过权限、不自动发消息。</a:t>
             </a:r>
           </a:p>
         </p:txBody>
@@ -7328,7 +7328,7 @@
           <p:cNvPr id="14" name="">
             <a:extLst xmlns:a="http://schemas.openxmlformats.org/drawingml/2006/main">
               <a:ext uri="{FF2B5EF4-FFF2-40B4-BE49-F238E27FC236}">
-                <a16:creationId xmlns:a16="http://schemas.microsoft.com/office/drawing/2014/main" id="{5469CEAD-89F7-4254-BA1F-BA9E4A171FC3}"/>
+                <a16:creationId xmlns:a16="http://schemas.microsoft.com/office/drawing/2014/main" id="{0CB3E803-CB03-40EC-8B93-40F3D9349109}"/>
               </a:ext>
             </a:extLst>
           </p:cNvPr>
@@ -7361,7 +7361,7 @@
           <p:cNvPr id="15" name="">
             <a:extLst xmlns:a="http://schemas.openxmlformats.org/drawingml/2006/main">
               <a:ext uri="{FF2B5EF4-FFF2-40B4-BE49-F238E27FC236}">
-                <a16:creationId xmlns:a16="http://schemas.microsoft.com/office/drawing/2014/main" id="{E14000E3-1BA2-4552-92FC-456BD2F4BA62}"/>
+                <a16:creationId xmlns:a16="http://schemas.microsoft.com/office/drawing/2014/main" id="{9F6A21A6-36F8-47B5-9B06-1B097961C2D8}"/>
               </a:ext>
             </a:extLst>
           </p:cNvPr>
@@ -7401,7 +7401,7 @@
                   <a:srgbClr val="310019"/>
                 </a:solidFill>
               </a:rPr>
-              <a:t>可退出</a:t>
+              <a:t>随时可以停</a:t>
             </a:r>
           </a:p>
         </p:txBody>
@@ -7411,7 +7411,7 @@
           <p:cNvPr id="16" name="">
             <a:extLst xmlns:a="http://schemas.openxmlformats.org/drawingml/2006/main">
               <a:ext uri="{FF2B5EF4-FFF2-40B4-BE49-F238E27FC236}">
-                <a16:creationId xmlns:a16="http://schemas.microsoft.com/office/drawing/2014/main" id="{7CA40766-92DF-46E2-A5FC-63F3C8056244}"/>
+                <a16:creationId xmlns:a16="http://schemas.microsoft.com/office/drawing/2014/main" id="{7AC616F0-E1AB-490D-AD42-22367A61FC20}"/>
               </a:ext>
             </a:extLst>
           </p:cNvPr>
@@ -7451,7 +7451,7 @@
                   <a:srgbClr val="25121D"/>
                 </a:solidFill>
               </a:rPr>
-              <a:t>临时模式不写长期记忆；记忆可更正、暂停、撤销，对象可归档。</a:t>
+              <a:t>临时问问不留长期记录；记忆可改、可撤回，人也可以归档。</a:t>
             </a:r>
           </a:p>
         </p:txBody>
@@ -7461,7 +7461,7 @@
           <p:cNvPr id="17" name="">
             <a:extLst xmlns:a="http://schemas.openxmlformats.org/drawingml/2006/main">
               <a:ext uri="{FF2B5EF4-FFF2-40B4-BE49-F238E27FC236}">
-                <a16:creationId xmlns:a16="http://schemas.microsoft.com/office/drawing/2014/main" id="{977463B1-B9C2-4AD4-96D0-41D1D5C08281}"/>
+                <a16:creationId xmlns:a16="http://schemas.microsoft.com/office/drawing/2014/main" id="{29F12B40-73C0-41BB-8357-FD979513A760}"/>
               </a:ext>
             </a:extLst>
           </p:cNvPr>
@@ -7494,7 +7494,7 @@
           <p:cNvPr id="18" name="">
             <a:extLst xmlns:a="http://schemas.openxmlformats.org/drawingml/2006/main">
               <a:ext uri="{FF2B5EF4-FFF2-40B4-BE49-F238E27FC236}">
-                <a16:creationId xmlns:a16="http://schemas.microsoft.com/office/drawing/2014/main" id="{7702F7A0-68C1-4130-BF4A-1E6016E9C013}"/>
+                <a16:creationId xmlns:a16="http://schemas.microsoft.com/office/drawing/2014/main" id="{058ABBC4-D060-471F-AA61-D10B5F98A83A}"/>
               </a:ext>
             </a:extLst>
           </p:cNvPr>
@@ -7544,7 +7544,7 @@
           <p:cNvPr id="19" name="">
             <a:extLst xmlns:a="http://schemas.openxmlformats.org/drawingml/2006/main">
               <a:ext uri="{FF2B5EF4-FFF2-40B4-BE49-F238E27FC236}">
-                <a16:creationId xmlns:a16="http://schemas.microsoft.com/office/drawing/2014/main" id="{B84C5DCA-339C-433B-A596-F265234705C9}"/>
+                <a16:creationId xmlns:a16="http://schemas.microsoft.com/office/drawing/2014/main" id="{E81CCFA1-176B-449A-AFB8-502EB8356986}"/>
               </a:ext>
             </a:extLst>
           </p:cNvPr>
@@ -7592,7 +7592,7 @@
     </p:spTree>
     <p:extLst>
       <p:ext uri="{BB962C8B-B14F-4D97-AF65-F5344CB8AC3E}">
-        <p14:creationId xmlns:p14="http://schemas.microsoft.com/office/powerpoint/2010/main" val="1425508460"/>
+        <p14:creationId xmlns:p14="http://schemas.microsoft.com/office/powerpoint/2010/main" val="1635840222"/>
       </p:ext>
     </p:extLst>
   </p:cSld>
@@ -7623,7 +7623,7 @@
           <p:cNvPr id="16" name="">
             <a:extLst xmlns:a="http://schemas.openxmlformats.org/drawingml/2006/main">
               <a:ext uri="{FF2B5EF4-FFF2-40B4-BE49-F238E27FC236}">
-                <a16:creationId xmlns:a16="http://schemas.microsoft.com/office/drawing/2014/main" id="{A5BB573D-C917-4BCD-A4DC-63C2D7B7033A}"/>
+                <a16:creationId xmlns:a16="http://schemas.microsoft.com/office/drawing/2014/main" id="{B02868EA-7317-4795-A3F5-63F89AB990EA}"/>
               </a:ext>
             </a:extLst>
           </p:cNvPr>
@@ -7663,7 +7663,7 @@
                   <a:srgbClr val="FF168F"/>
                 </a:solidFill>
               </a:rPr>
-              <a:t>07 · PROOF</a:t>
+              <a:t>07 · 现在做到哪了</a:t>
             </a:r>
           </a:p>
         </p:txBody>
@@ -7673,7 +7673,7 @@
           <p:cNvPr id="2" name="">
             <a:extLst xmlns:a="http://schemas.openxmlformats.org/drawingml/2006/main">
               <a:ext uri="{FF2B5EF4-FFF2-40B4-BE49-F238E27FC236}">
-                <a16:creationId xmlns:a16="http://schemas.microsoft.com/office/drawing/2014/main" id="{CA41D6F9-027A-404B-B298-27811653BB65}"/>
+                <a16:creationId xmlns:a16="http://schemas.microsoft.com/office/drawing/2014/main" id="{280C51D1-E1B9-42CB-A0D6-DD218A6E9D81}"/>
               </a:ext>
             </a:extLst>
           </p:cNvPr>
@@ -7713,7 +7713,7 @@
                   <a:srgbClr val="FFFFFF"/>
                 </a:solidFill>
               </a:rPr>
-              <a:t>第一版已经可运行、可验证、可复核</a:t>
+              <a:t>现在已经能跑，不是只写了一个想法</a:t>
             </a:r>
           </a:p>
         </p:txBody>
@@ -7723,7 +7723,7 @@
           <p:cNvPr id="3" name="">
             <a:extLst xmlns:a="http://schemas.openxmlformats.org/drawingml/2006/main">
               <a:ext uri="{FF2B5EF4-FFF2-40B4-BE49-F238E27FC236}">
-                <a16:creationId xmlns:a16="http://schemas.microsoft.com/office/drawing/2014/main" id="{2E3C90C5-DB86-456B-B9F8-5DF72D883FA9}"/>
+                <a16:creationId xmlns:a16="http://schemas.microsoft.com/office/drawing/2014/main" id="{77DF6865-204B-48D0-B7B4-479579445466}"/>
               </a:ext>
             </a:extLst>
           </p:cNvPr>
@@ -7763,7 +7763,7 @@
                   <a:srgbClr val="E9CAD9"/>
                 </a:solidFill>
               </a:rPr>
-              <a:t>公开合成数据贯穿完整 Demo；无需真实聊天，也无需 API Key。</a:t>
+              <a:t>用公开假数据就能完整演示，不用真实聊天，也不用 API Key。</a:t>
             </a:r>
           </a:p>
         </p:txBody>
@@ -7773,7 +7773,7 @@
           <p:cNvPr id="4" name="">
             <a:extLst xmlns:a="http://schemas.openxmlformats.org/drawingml/2006/main">
               <a:ext uri="{FF2B5EF4-FFF2-40B4-BE49-F238E27FC236}">
-                <a16:creationId xmlns:a16="http://schemas.microsoft.com/office/drawing/2014/main" id="{BE3FD5D2-B765-42B7-BF6D-33BEFF2FBE2E}"/>
+                <a16:creationId xmlns:a16="http://schemas.microsoft.com/office/drawing/2014/main" id="{1EB95E60-716F-4DA7-8AEC-DA7806A73578}"/>
               </a:ext>
             </a:extLst>
           </p:cNvPr>
@@ -7823,7 +7823,7 @@
           <p:cNvPr id="5" name="">
             <a:extLst xmlns:a="http://schemas.openxmlformats.org/drawingml/2006/main">
               <a:ext uri="{FF2B5EF4-FFF2-40B4-BE49-F238E27FC236}">
-                <a16:creationId xmlns:a16="http://schemas.microsoft.com/office/drawing/2014/main" id="{231681E8-16AF-4CC8-877F-A886A02AAB5E}"/>
+                <a16:creationId xmlns:a16="http://schemas.microsoft.com/office/drawing/2014/main" id="{961403AA-9130-441E-9EAF-4D32A0293AFE}"/>
               </a:ext>
             </a:extLst>
           </p:cNvPr>
@@ -7863,7 +7863,7 @@
                   <a:srgbClr val="D9B8C9"/>
                 </a:solidFill>
               </a:rPr>
-              <a:t>自动化测试通过</a:t>
+              <a:t>测试全部通过</a:t>
             </a:r>
           </a:p>
         </p:txBody>
@@ -7873,7 +7873,7 @@
           <p:cNvPr id="6" name="">
             <a:extLst xmlns:a="http://schemas.openxmlformats.org/drawingml/2006/main">
               <a:ext uri="{FF2B5EF4-FFF2-40B4-BE49-F238E27FC236}">
-                <a16:creationId xmlns:a16="http://schemas.microsoft.com/office/drawing/2014/main" id="{58DFAF92-9F01-402F-ADB0-04CE40B46C51}"/>
+                <a16:creationId xmlns:a16="http://schemas.microsoft.com/office/drawing/2014/main" id="{7EAAB882-6A01-45BE-8CD0-0B0C8065F68D}"/>
               </a:ext>
             </a:extLst>
           </p:cNvPr>
@@ -7923,7 +7923,7 @@
           <p:cNvPr id="7" name="">
             <a:extLst xmlns:a="http://schemas.openxmlformats.org/drawingml/2006/main">
               <a:ext uri="{FF2B5EF4-FFF2-40B4-BE49-F238E27FC236}">
-                <a16:creationId xmlns:a16="http://schemas.microsoft.com/office/drawing/2014/main" id="{62D93EB4-D854-4943-A2B6-B89B49641100}"/>
+                <a16:creationId xmlns:a16="http://schemas.microsoft.com/office/drawing/2014/main" id="{B01DA84B-95A2-403D-BF62-7ACCD106C3FD}"/>
               </a:ext>
             </a:extLst>
           </p:cNvPr>
@@ -7963,7 +7963,7 @@
                   <a:srgbClr val="D9B8C9"/>
                 </a:solidFill>
               </a:rPr>
-              <a:t>证据 K 线事件</a:t>
+              <a:t>公开关系记录</a:t>
             </a:r>
           </a:p>
         </p:txBody>
@@ -7973,7 +7973,7 @@
           <p:cNvPr id="8" name="">
             <a:extLst xmlns:a="http://schemas.openxmlformats.org/drawingml/2006/main">
               <a:ext uri="{FF2B5EF4-FFF2-40B4-BE49-F238E27FC236}">
-                <a16:creationId xmlns:a16="http://schemas.microsoft.com/office/drawing/2014/main" id="{2B81958B-D88C-450A-B010-D22DDF5502F0}"/>
+                <a16:creationId xmlns:a16="http://schemas.microsoft.com/office/drawing/2014/main" id="{95D51BE2-8135-4315-A788-BCA7BEECF155}"/>
               </a:ext>
             </a:extLst>
           </p:cNvPr>
@@ -8023,7 +8023,7 @@
           <p:cNvPr id="9" name="">
             <a:extLst xmlns:a="http://schemas.openxmlformats.org/drawingml/2006/main">
               <a:ext uri="{FF2B5EF4-FFF2-40B4-BE49-F238E27FC236}">
-                <a16:creationId xmlns:a16="http://schemas.microsoft.com/office/drawing/2014/main" id="{068B17A8-7BEC-4F1F-9FDB-093FEFC1C8C2}"/>
+                <a16:creationId xmlns:a16="http://schemas.microsoft.com/office/drawing/2014/main" id="{6FD720F6-80EB-4E40-BEC2-9DC2A226EC0B}"/>
               </a:ext>
             </a:extLst>
           </p:cNvPr>
@@ -8063,7 +8063,7 @@
                   <a:srgbClr val="D9B8C9"/>
                 </a:solidFill>
               </a:rPr>
-              <a:t>对象上限与隔离</a:t>
+              <a:t>最多可建档人数</a:t>
             </a:r>
           </a:p>
         </p:txBody>
@@ -8073,7 +8073,7 @@
           <p:cNvPr id="10" name="">
             <a:extLst xmlns:a="http://schemas.openxmlformats.org/drawingml/2006/main">
               <a:ext uri="{FF2B5EF4-FFF2-40B4-BE49-F238E27FC236}">
-                <a16:creationId xmlns:a16="http://schemas.microsoft.com/office/drawing/2014/main" id="{680F7230-11FF-49D8-8E3D-B17BC2474FCB}"/>
+                <a16:creationId xmlns:a16="http://schemas.microsoft.com/office/drawing/2014/main" id="{0212AE00-8B9F-457B-A426-8CFC5DEB2B33}"/>
               </a:ext>
             </a:extLst>
           </p:cNvPr>
@@ -8123,7 +8123,7 @@
           <p:cNvPr id="11" name="">
             <a:extLst xmlns:a="http://schemas.openxmlformats.org/drawingml/2006/main">
               <a:ext uri="{FF2B5EF4-FFF2-40B4-BE49-F238E27FC236}">
-                <a16:creationId xmlns:a16="http://schemas.microsoft.com/office/drawing/2014/main" id="{66665800-0F95-43F2-A781-30BEC90B9C68}"/>
+                <a16:creationId xmlns:a16="http://schemas.microsoft.com/office/drawing/2014/main" id="{4BCCF2CE-4147-4ED3-8B0E-689C1FDCECEF}"/>
               </a:ext>
             </a:extLst>
           </p:cNvPr>
@@ -8163,7 +8163,7 @@
                   <a:srgbClr val="D9B8C9"/>
                 </a:solidFill>
               </a:rPr>
-              <a:t>单次按需参考</a:t>
+              <a:t>每次只查少量资料</a:t>
             </a:r>
           </a:p>
         </p:txBody>
@@ -8173,7 +8173,7 @@
           <p:cNvPr id="12" name="">
             <a:extLst xmlns:a="http://schemas.openxmlformats.org/drawingml/2006/main">
               <a:ext uri="{FF2B5EF4-FFF2-40B4-BE49-F238E27FC236}">
-                <a16:creationId xmlns:a16="http://schemas.microsoft.com/office/drawing/2014/main" id="{4EE880FF-3A41-437A-A18C-ED0F49AE4068}"/>
+                <a16:creationId xmlns:a16="http://schemas.microsoft.com/office/drawing/2014/main" id="{A3E5A0A8-A689-436F-B450-CF74AD0235EE}"/>
               </a:ext>
             </a:extLst>
           </p:cNvPr>
@@ -8212,7 +8212,7 @@
           <p:nvPr/>
         </p:nvPicPr>
         <p:blipFill>
-          <a:blip xmlns:r="http://schemas.openxmlformats.org/officeDocument/2006/relationships" xmlns:a="http://schemas.openxmlformats.org/drawingml/2006/main" r:embed="R280eb31933324b45"/>
+          <a:blip xmlns:r="http://schemas.openxmlformats.org/officeDocument/2006/relationships" xmlns:a="http://schemas.openxmlformats.org/drawingml/2006/main" r:embed="R96fdc497540344c3"/>
           <a:stretch xmlns:a="http://schemas.openxmlformats.org/drawingml/2006/main"/>
         </p:blipFill>
         <p:spPr>
@@ -8232,7 +8232,7 @@
           <p:cNvPr id="14" name="">
             <a:extLst xmlns:a="http://schemas.openxmlformats.org/drawingml/2006/main">
               <a:ext uri="{FF2B5EF4-FFF2-40B4-BE49-F238E27FC236}">
-                <a16:creationId xmlns:a16="http://schemas.microsoft.com/office/drawing/2014/main" id="{AED86C71-58C4-449F-8CF1-D3E9C07C7BB9}"/>
+                <a16:creationId xmlns:a16="http://schemas.microsoft.com/office/drawing/2014/main" id="{BB6E0C0C-31FA-4816-A4D0-D657C63C7BC0}"/>
               </a:ext>
             </a:extLst>
           </p:cNvPr>
@@ -8282,7 +8282,7 @@
           <p:cNvPr id="15" name="">
             <a:extLst xmlns:a="http://schemas.openxmlformats.org/drawingml/2006/main">
               <a:ext uri="{FF2B5EF4-FFF2-40B4-BE49-F238E27FC236}">
-                <a16:creationId xmlns:a16="http://schemas.microsoft.com/office/drawing/2014/main" id="{8EF08BBD-75C0-4CB2-8681-AB70C84C563F}"/>
+                <a16:creationId xmlns:a16="http://schemas.microsoft.com/office/drawing/2014/main" id="{0B941178-80C8-4978-9A97-8A5D8766A149}"/>
               </a:ext>
             </a:extLst>
           </p:cNvPr>
@@ -8330,7 +8330,7 @@
     </p:spTree>
     <p:extLst>
       <p:ext uri="{BB962C8B-B14F-4D97-AF65-F5344CB8AC3E}">
-        <p14:creationId xmlns:p14="http://schemas.microsoft.com/office/powerpoint/2010/main" val="970730775"/>
+        <p14:creationId xmlns:p14="http://schemas.microsoft.com/office/powerpoint/2010/main" val="943106887"/>
       </p:ext>
     </p:extLst>
   </p:cSld>
@@ -8361,7 +8361,7 @@
           <p:cNvPr id="24" name="">
             <a:extLst xmlns:a="http://schemas.openxmlformats.org/drawingml/2006/main">
               <a:ext uri="{FF2B5EF4-FFF2-40B4-BE49-F238E27FC236}">
-                <a16:creationId xmlns:a16="http://schemas.microsoft.com/office/drawing/2014/main" id="{17A39F8D-1F42-438D-97D8-94A07324C266}"/>
+                <a16:creationId xmlns:a16="http://schemas.microsoft.com/office/drawing/2014/main" id="{03DFF2C9-73E8-4244-8CEC-9310C7333FC3}"/>
               </a:ext>
             </a:extLst>
           </p:cNvPr>
@@ -8401,7 +8401,7 @@
                   <a:srgbClr val="FF168F"/>
                 </a:solidFill>
               </a:rPr>
-              <a:t>08 · OPEN SOURCE</a:t>
+              <a:t>08 · 别人也能拿去用</a:t>
             </a:r>
           </a:p>
         </p:txBody>
@@ -8411,7 +8411,7 @@
           <p:cNvPr id="2" name="">
             <a:extLst xmlns:a="http://schemas.openxmlformats.org/drawingml/2006/main">
               <a:ext uri="{FF2B5EF4-FFF2-40B4-BE49-F238E27FC236}">
-                <a16:creationId xmlns:a16="http://schemas.microsoft.com/office/drawing/2014/main" id="{FE9CBE09-AE75-4294-B90C-09FD6A72B5C8}"/>
+                <a16:creationId xmlns:a16="http://schemas.microsoft.com/office/drawing/2014/main" id="{43494441-6407-4323-96A2-1D5121F8430D}"/>
               </a:ext>
             </a:extLst>
           </p:cNvPr>
@@ -8451,7 +8451,7 @@
                   <a:srgbClr val="25121D"/>
                 </a:solidFill>
               </a:rPr>
-              <a:t>开源的不是一个页面，而是一套可迁移的 Agent 模板</a:t>
+              <a:t>别人不用从头再做，可以直接拿去改</a:t>
             </a:r>
           </a:p>
         </p:txBody>
@@ -8461,7 +8461,7 @@
           <p:cNvPr id="3" name="">
             <a:extLst xmlns:a="http://schemas.openxmlformats.org/drawingml/2006/main">
               <a:ext uri="{FF2B5EF4-FFF2-40B4-BE49-F238E27FC236}">
-                <a16:creationId xmlns:a16="http://schemas.microsoft.com/office/drawing/2014/main" id="{261FBFA9-C0E1-4377-921E-A4E631FD8582}"/>
+                <a16:creationId xmlns:a16="http://schemas.microsoft.com/office/drawing/2014/main" id="{B4DC64C4-68D1-486A-A71B-4C8F39899F1F}"/>
               </a:ext>
             </a:extLst>
           </p:cNvPr>
@@ -8501,7 +8501,7 @@
                   <a:srgbClr val="765C6A"/>
                 </a:solidFill>
               </a:rPr>
-              <a:t>其他高情绪、低确定性的个人决策场景，可以复用同一套证据与确认协议。</a:t>
+              <a:t>这套做法还能用在其他“心里很乱、又很难判断”的个人问题上。</a:t>
             </a:r>
           </a:p>
         </p:txBody>
@@ -8511,7 +8511,7 @@
           <p:cNvPr id="4" name="">
             <a:extLst xmlns:a="http://schemas.openxmlformats.org/drawingml/2006/main">
               <a:ext uri="{FF2B5EF4-FFF2-40B4-BE49-F238E27FC236}">
-                <a16:creationId xmlns:a16="http://schemas.microsoft.com/office/drawing/2014/main" id="{BA2BE941-13C8-4B78-AC95-4C390288821E}"/>
+                <a16:creationId xmlns:a16="http://schemas.microsoft.com/office/drawing/2014/main" id="{B17BC105-B2D2-463A-B624-3459AF45AF2B}"/>
               </a:ext>
             </a:extLst>
           </p:cNvPr>
@@ -8551,7 +8551,7 @@
                   <a:srgbClr val="FF168F"/>
                 </a:solidFill>
               </a:rPr>
-              <a:t>Harness bundle / plugin</a:t>
+              <a:t>接入 DeepSeek 的方法</a:t>
             </a:r>
           </a:p>
         </p:txBody>
@@ -8561,7 +8561,7 @@
           <p:cNvPr id="5" name="">
             <a:extLst xmlns:a="http://schemas.openxmlformats.org/drawingml/2006/main">
               <a:ext uri="{FF2B5EF4-FFF2-40B4-BE49-F238E27FC236}">
-                <a16:creationId xmlns:a16="http://schemas.microsoft.com/office/drawing/2014/main" id="{12444AA5-99F0-415E-B503-B753A2E0BC4F}"/>
+                <a16:creationId xmlns:a16="http://schemas.microsoft.com/office/drawing/2014/main" id="{0080AFE7-8565-412F-B3DE-BB68667E94EB}"/>
               </a:ext>
             </a:extLst>
           </p:cNvPr>
@@ -8601,7 +8601,7 @@
                   <a:srgbClr val="25121D"/>
                 </a:solidFill>
               </a:rPr>
-              <a:t>把垂直 Agent 镶入官方运行底座</a:t>
+              <a:t>让狗头军师真正运行在 DeepSeek 里</a:t>
             </a:r>
           </a:p>
         </p:txBody>
@@ -8611,7 +8611,7 @@
           <p:cNvPr id="6" name="">
             <a:extLst xmlns:a="http://schemas.openxmlformats.org/drawingml/2006/main">
               <a:ext uri="{FF2B5EF4-FFF2-40B4-BE49-F238E27FC236}">
-                <a16:creationId xmlns:a16="http://schemas.microsoft.com/office/drawing/2014/main" id="{34A67158-06D5-4A0B-8193-EF74D1CBC0DE}"/>
+                <a16:creationId xmlns:a16="http://schemas.microsoft.com/office/drawing/2014/main" id="{2DAB2E00-CF9E-4B88-9F84-1D4343293DD6}"/>
               </a:ext>
             </a:extLst>
           </p:cNvPr>
@@ -8644,7 +8644,7 @@
           <p:cNvPr id="7" name="">
             <a:extLst xmlns:a="http://schemas.openxmlformats.org/drawingml/2006/main">
               <a:ext uri="{FF2B5EF4-FFF2-40B4-BE49-F238E27FC236}">
-                <a16:creationId xmlns:a16="http://schemas.microsoft.com/office/drawing/2014/main" id="{08B5CD40-721B-4B98-8BE3-B485A5C93F75}"/>
+                <a16:creationId xmlns:a16="http://schemas.microsoft.com/office/drawing/2014/main" id="{32050A40-1349-486C-9B60-742A856DBF77}"/>
               </a:ext>
             </a:extLst>
           </p:cNvPr>
@@ -8684,7 +8684,7 @@
                   <a:srgbClr val="310019"/>
                 </a:solidFill>
               </a:rPr>
-              <a:t>Reference router</a:t>
+              <a:t>按问题查资料</a:t>
             </a:r>
           </a:p>
         </p:txBody>
@@ -8694,7 +8694,7 @@
           <p:cNvPr id="8" name="">
             <a:extLst xmlns:a="http://schemas.openxmlformats.org/drawingml/2006/main">
               <a:ext uri="{FF2B5EF4-FFF2-40B4-BE49-F238E27FC236}">
-                <a16:creationId xmlns:a16="http://schemas.microsoft.com/office/drawing/2014/main" id="{D25EEC16-2544-482B-A6D2-3740FE2B14DC}"/>
+                <a16:creationId xmlns:a16="http://schemas.microsoft.com/office/drawing/2014/main" id="{1ED0C658-EC29-44D3-B28C-428C7F5E38A0}"/>
               </a:ext>
             </a:extLst>
           </p:cNvPr>
@@ -8734,7 +8734,7 @@
                   <a:srgbClr val="25121D"/>
                 </a:solidFill>
               </a:rPr>
-              <a:t>按问题渐进加载 1–3 份领域参考</a:t>
+              <a:t>每次只找当前问题需要的 1–3 份内容</a:t>
             </a:r>
           </a:p>
         </p:txBody>
@@ -8744,7 +8744,7 @@
           <p:cNvPr id="9" name="">
             <a:extLst xmlns:a="http://schemas.openxmlformats.org/drawingml/2006/main">
               <a:ext uri="{FF2B5EF4-FFF2-40B4-BE49-F238E27FC236}">
-                <a16:creationId xmlns:a16="http://schemas.microsoft.com/office/drawing/2014/main" id="{4EA3A381-710A-4230-AA98-AE25E7F88BCC}"/>
+                <a16:creationId xmlns:a16="http://schemas.microsoft.com/office/drawing/2014/main" id="{04600B4B-8575-445B-808A-ED8AF2D076F0}"/>
               </a:ext>
             </a:extLst>
           </p:cNvPr>
@@ -8777,7 +8777,7 @@
           <p:cNvPr id="10" name="">
             <a:extLst xmlns:a="http://schemas.openxmlformats.org/drawingml/2006/main">
               <a:ext uri="{FF2B5EF4-FFF2-40B4-BE49-F238E27FC236}">
-                <a16:creationId xmlns:a16="http://schemas.microsoft.com/office/drawing/2014/main" id="{FA76A7E0-9F19-421D-BF12-9B7C33FA7FD7}"/>
+                <a16:creationId xmlns:a16="http://schemas.microsoft.com/office/drawing/2014/main" id="{2F04BDBB-9A54-4F31-910F-604356EF022E}"/>
               </a:ext>
             </a:extLst>
           </p:cNvPr>
@@ -8817,7 +8817,7 @@
                   <a:srgbClr val="310019"/>
                 </a:solidFill>
               </a:rPr>
-              <a:t>Identity + evidence</a:t>
+              <a:t>确认聊天双方</a:t>
             </a:r>
           </a:p>
         </p:txBody>
@@ -8827,7 +8827,7 @@
           <p:cNvPr id="11" name="">
             <a:extLst xmlns:a="http://schemas.openxmlformats.org/drawingml/2006/main">
               <a:ext uri="{FF2B5EF4-FFF2-40B4-BE49-F238E27FC236}">
-                <a16:creationId xmlns:a16="http://schemas.microsoft.com/office/drawing/2014/main" id="{C48C1265-179E-4633-BB5D-9618AFC8345C}"/>
+                <a16:creationId xmlns:a16="http://schemas.microsoft.com/office/drawing/2014/main" id="{7CC5EE38-B127-4BB9-8242-A98ED31972B4}"/>
               </a:ext>
             </a:extLst>
           </p:cNvPr>
@@ -8867,7 +8867,7 @@
                   <a:srgbClr val="25121D"/>
                 </a:solidFill>
               </a:rPr>
-              <a:t>身份锚点、冲突停止、来源引用</a:t>
+              <a:t>先确认谁是谁，对不上就停止</a:t>
             </a:r>
           </a:p>
         </p:txBody>
@@ -8877,7 +8877,7 @@
           <p:cNvPr id="12" name="">
             <a:extLst xmlns:a="http://schemas.openxmlformats.org/drawingml/2006/main">
               <a:ext uri="{FF2B5EF4-FFF2-40B4-BE49-F238E27FC236}">
-                <a16:creationId xmlns:a16="http://schemas.microsoft.com/office/drawing/2014/main" id="{9C71FA5E-D2EC-4B44-B023-BF7F348AF94A}"/>
+                <a16:creationId xmlns:a16="http://schemas.microsoft.com/office/drawing/2014/main" id="{4120BD51-F695-480D-8154-969D695C30DD}"/>
               </a:ext>
             </a:extLst>
           </p:cNvPr>
@@ -8910,7 +8910,7 @@
           <p:cNvPr id="13" name="">
             <a:extLst xmlns:a="http://schemas.openxmlformats.org/drawingml/2006/main">
               <a:ext uri="{FF2B5EF4-FFF2-40B4-BE49-F238E27FC236}">
-                <a16:creationId xmlns:a16="http://schemas.microsoft.com/office/drawing/2014/main" id="{F081A7F3-9DEA-4BDE-9188-4D95EC3EEEDB}"/>
+                <a16:creationId xmlns:a16="http://schemas.microsoft.com/office/drawing/2014/main" id="{5DAD0278-570E-49CD-BDF1-7569348C8963}"/>
               </a:ext>
             </a:extLst>
           </p:cNvPr>
@@ -8950,7 +8950,7 @@
                   <a:srgbClr val="310019"/>
                 </a:solidFill>
               </a:rPr>
-              <a:t>Memory adapter</a:t>
+              <a:t>每个人资料分开</a:t>
             </a:r>
           </a:p>
         </p:txBody>
@@ -8960,7 +8960,7 @@
           <p:cNvPr id="14" name="">
             <a:extLst xmlns:a="http://schemas.openxmlformats.org/drawingml/2006/main">
               <a:ext uri="{FF2B5EF4-FFF2-40B4-BE49-F238E27FC236}">
-                <a16:creationId xmlns:a16="http://schemas.microsoft.com/office/drawing/2014/main" id="{2ACB4C46-75B4-4BE5-A81D-8780B1E159DE}"/>
+                <a16:creationId xmlns:a16="http://schemas.microsoft.com/office/drawing/2014/main" id="{4ACF1033-2965-4353-9FF5-87B3E439A7F2}"/>
               </a:ext>
             </a:extLst>
           </p:cNvPr>
@@ -9000,7 +9000,7 @@
                   <a:srgbClr val="25121D"/>
                 </a:solidFill>
               </a:rPr>
-              <a:t>对象隔离、压缩、撤销与删除</a:t>
+              <a:t>记忆不串档，也能撤回和删除</a:t>
             </a:r>
           </a:p>
         </p:txBody>
@@ -9010,7 +9010,7 @@
           <p:cNvPr id="15" name="">
             <a:extLst xmlns:a="http://schemas.openxmlformats.org/drawingml/2006/main">
               <a:ext uri="{FF2B5EF4-FFF2-40B4-BE49-F238E27FC236}">
-                <a16:creationId xmlns:a16="http://schemas.microsoft.com/office/drawing/2014/main" id="{1E331D0F-2044-47F5-AFA0-407CA733F4AC}"/>
+                <a16:creationId xmlns:a16="http://schemas.microsoft.com/office/drawing/2014/main" id="{57445407-262C-4025-8CB5-76C0423EA3D7}"/>
               </a:ext>
             </a:extLst>
           </p:cNvPr>
@@ -9043,7 +9043,7 @@
           <p:cNvPr id="16" name="">
             <a:extLst xmlns:a="http://schemas.openxmlformats.org/drawingml/2006/main">
               <a:ext uri="{FF2B5EF4-FFF2-40B4-BE49-F238E27FC236}">
-                <a16:creationId xmlns:a16="http://schemas.microsoft.com/office/drawing/2014/main" id="{02FAE7F5-ABF9-46D8-93C4-7ECAA0E4C22B}"/>
+                <a16:creationId xmlns:a16="http://schemas.microsoft.com/office/drawing/2014/main" id="{C07DC260-2F74-42F6-808E-1672F9D348F4}"/>
               </a:ext>
             </a:extLst>
           </p:cNvPr>
@@ -9083,7 +9083,7 @@
                   <a:srgbClr val="310019"/>
                 </a:solidFill>
               </a:rPr>
-              <a:t>Public Demo + tests</a:t>
+              <a:t>公开案例和测试</a:t>
             </a:r>
           </a:p>
         </p:txBody>
@@ -9093,7 +9093,7 @@
           <p:cNvPr id="17" name="">
             <a:extLst xmlns:a="http://schemas.openxmlformats.org/drawingml/2006/main">
               <a:ext uri="{FF2B5EF4-FFF2-40B4-BE49-F238E27FC236}">
-                <a16:creationId xmlns:a16="http://schemas.microsoft.com/office/drawing/2014/main" id="{773DCF7B-7099-4D58-BD55-775E174DE2DE}"/>
+                <a16:creationId xmlns:a16="http://schemas.microsoft.com/office/drawing/2014/main" id="{A1C1BCD1-EFCD-4DC5-BF52-2622FAD7D8FE}"/>
               </a:ext>
             </a:extLst>
           </p:cNvPr>
@@ -9133,7 +9133,7 @@
                   <a:srgbClr val="25121D"/>
                 </a:solidFill>
               </a:rPr>
-              <a:t>合成数据、运行入口、自动化验证</a:t>
+              <a:t>不用真实聊天也能运行和检查</a:t>
             </a:r>
           </a:p>
         </p:txBody>
@@ -9143,7 +9143,7 @@
           <p:cNvPr id="18" name="">
             <a:extLst xmlns:a="http://schemas.openxmlformats.org/drawingml/2006/main">
               <a:ext uri="{FF2B5EF4-FFF2-40B4-BE49-F238E27FC236}">
-                <a16:creationId xmlns:a16="http://schemas.microsoft.com/office/drawing/2014/main" id="{97B8A4A3-205F-4767-B14A-901249B3A816}"/>
+                <a16:creationId xmlns:a16="http://schemas.microsoft.com/office/drawing/2014/main" id="{07E21B92-D5A3-49B9-BFCC-9E9F4E7E9837}"/>
               </a:ext>
             </a:extLst>
           </p:cNvPr>
@@ -9176,7 +9176,7 @@
           <p:cNvPr id="19" name="">
             <a:extLst xmlns:a="http://schemas.openxmlformats.org/drawingml/2006/main">
               <a:ext uri="{FF2B5EF4-FFF2-40B4-BE49-F238E27FC236}">
-                <a16:creationId xmlns:a16="http://schemas.microsoft.com/office/drawing/2014/main" id="{F82BA5E1-C42C-4B13-B772-821ABE7B24A7}"/>
+                <a16:creationId xmlns:a16="http://schemas.microsoft.com/office/drawing/2014/main" id="{CC6C5F95-70B6-4951-9DE2-6EAAFEB3CF73}"/>
               </a:ext>
             </a:extLst>
           </p:cNvPr>
@@ -9188,7 +9188,7 @@
         <p:spPr>
           <a:xfrm xmlns:a="http://schemas.openxmlformats.org/drawingml/2006/main">
             <a:off x="723900" y="6115050"/>
-            <a:ext cx="2876550" cy="323850"/>
+            <a:ext cx="2476500" cy="323850"/>
           </a:xfrm>
           <a:prstGeom xmlns:a="http://schemas.openxmlformats.org/drawingml/2006/main" prst="roundRect">
             <a:avLst>
@@ -9209,7 +9209,7 @@
           <p:cNvPr id="20" name="">
             <a:extLst xmlns:a="http://schemas.openxmlformats.org/drawingml/2006/main">
               <a:ext uri="{FF2B5EF4-FFF2-40B4-BE49-F238E27FC236}">
-                <a16:creationId xmlns:a16="http://schemas.microsoft.com/office/drawing/2014/main" id="{7EB2FE04-8AAE-441D-B50C-7F5806328C17}"/>
+                <a16:creationId xmlns:a16="http://schemas.microsoft.com/office/drawing/2014/main" id="{96F6BCFD-94F9-49F1-8AC2-0BEF8EE4CD7C}"/>
               </a:ext>
             </a:extLst>
           </p:cNvPr>
@@ -9221,7 +9221,7 @@
         <p:spPr>
           <a:xfrm xmlns:a="http://schemas.openxmlformats.org/drawingml/2006/main">
             <a:off x="838200" y="6162675"/>
-            <a:ext cx="2647950" cy="228600"/>
+            <a:ext cx="2247900" cy="228600"/>
           </a:xfrm>
           <a:prstGeom xmlns:a="http://schemas.openxmlformats.org/drawingml/2006/main" prst="rect">
             <a:avLst/>
@@ -9249,7 +9249,7 @@
                   <a:srgbClr val="FFFFFF"/>
                 </a:solidFill>
               </a:rPr>
-              <a:t>MIT-compatible third-party notices</a:t>
+              <a:t>代码和第三方说明都公开</a:t>
             </a:r>
           </a:p>
         </p:txBody>
@@ -9259,7 +9259,7 @@
           <p:cNvPr id="21" name="">
             <a:extLst xmlns:a="http://schemas.openxmlformats.org/drawingml/2006/main">
               <a:ext uri="{FF2B5EF4-FFF2-40B4-BE49-F238E27FC236}">
-                <a16:creationId xmlns:a16="http://schemas.microsoft.com/office/drawing/2014/main" id="{53B61E0E-C7D1-4B96-9AD1-5A014FF777FA}"/>
+                <a16:creationId xmlns:a16="http://schemas.microsoft.com/office/drawing/2014/main" id="{6BB4DABF-6E5B-49AB-B452-3BE2A9C6F610}"/>
               </a:ext>
             </a:extLst>
           </p:cNvPr>
@@ -9309,7 +9309,7 @@
           <p:cNvPr id="22" name="">
             <a:extLst xmlns:a="http://schemas.openxmlformats.org/drawingml/2006/main">
               <a:ext uri="{FF2B5EF4-FFF2-40B4-BE49-F238E27FC236}">
-                <a16:creationId xmlns:a16="http://schemas.microsoft.com/office/drawing/2014/main" id="{AE80DD0D-90C5-42D7-9093-C2638D1229DE}"/>
+                <a16:creationId xmlns:a16="http://schemas.microsoft.com/office/drawing/2014/main" id="{879929CC-2A63-4AD6-A73E-02012814FDCB}"/>
               </a:ext>
             </a:extLst>
           </p:cNvPr>
@@ -9359,7 +9359,7 @@
           <p:cNvPr id="23" name="">
             <a:extLst xmlns:a="http://schemas.openxmlformats.org/drawingml/2006/main">
               <a:ext uri="{FF2B5EF4-FFF2-40B4-BE49-F238E27FC236}">
-                <a16:creationId xmlns:a16="http://schemas.microsoft.com/office/drawing/2014/main" id="{C3AEA421-9FBA-481B-8EB4-D801172704CD}"/>
+                <a16:creationId xmlns:a16="http://schemas.microsoft.com/office/drawing/2014/main" id="{81C0A0F5-689B-4320-9D63-BD04826113F0}"/>
               </a:ext>
             </a:extLst>
           </p:cNvPr>
@@ -9407,7 +9407,7 @@
     </p:spTree>
     <p:extLst>
       <p:ext uri="{BB962C8B-B14F-4D97-AF65-F5344CB8AC3E}">
-        <p14:creationId xmlns:p14="http://schemas.microsoft.com/office/powerpoint/2010/main" val="1398972283"/>
+        <p14:creationId xmlns:p14="http://schemas.microsoft.com/office/powerpoint/2010/main" val="1957650265"/>
       </p:ext>
     </p:extLst>
   </p:cSld>

</xml_diff>